<commit_message>
Welle 3: VA00 kuratiertes Deck + 2 Schaubilder (Web/Admin/Workbook)
Co-Authored-By: Claude Fable 5 <noreply@anthropic.com>
</commit_message>
<xml_diff>
--- a/protected-downloads/praesentation/VA00.pptx
+++ b/protected-downloads/praesentation/VA00.pptx
@@ -14,6 +14,13 @@
     <p:sldId id="262" r:id="rId14"/>
     <p:sldId id="263" r:id="rId15"/>
     <p:sldId id="264" r:id="rId16"/>
+    <p:sldId id="265" r:id="rId17"/>
+    <p:sldId id="266" r:id="rId18"/>
+    <p:sldId id="267" r:id="rId19"/>
+    <p:sldId id="268" r:id="rId20"/>
+    <p:sldId id="269" r:id="rId21"/>
+    <p:sldId id="270" r:id="rId22"/>
+    <p:sldId id="271" r:id="rId23"/>
   </p:sldIdLst>
   <p:sldSz cx="12188952" cy="6858000" type="screen4x3"/>
   <p:notesSz cx="6858000" cy="9144000"/>
@@ -580,7 +587,7 @@
           <a:lstStyle/>
           <a:p>
             <a:r>
-              <a:t>Siehe Trainerhandbuch (Sektion 3) für Moderationshinweise, Timing und erwartete Teilnehmerreaktionen.</a:t>
+              <a:t>Einstiegsfrage: „Welche Produktnamen, Systemkürzel oder Abteilungen kennen Sie schon?" Antworten an der Flipchart sammeln – am Ende bekommt jeder Begriff einen Platz auf der Landkarte.</a:t>
             </a:r>
           </a:p>
         </p:txBody>
@@ -650,7 +657,7 @@
           <a:lstStyle/>
           <a:p>
             <a:r>
-              <a:t>Siehe Trainerhandbuch (Sektion 3) für Moderationshinweise, Timing und erwartete Teilnehmerreaktionen.</a:t>
+              <a:t>Eine mentale Landkarte des eigenen Hauses ist die Voraussetzung, um schnell handlungsfähig zu werden (Lave &amp; Wenger, 1991). Auf gesammelte Flipchart-Begriffe zurückverweisen.</a:t>
             </a:r>
           </a:p>
         </p:txBody>
@@ -720,42 +727,7 @@
           <a:lstStyle/>
           <a:p>
             <a:r>
-              <a:t>Trainer-Hinweis: Musterlösung im AB-2 Trainer-Abschnitt unten. Hinweis für Teilnehmer: Es kann mehr als eine richtige Antwort geben – das ist im Verbund normal.</a:t>
-            </a:r>
-          </a:p>
-          <a:p>
-            <a:r>
-              <a:t>AB-2 Musterlösung (Trainer-Version)</a:t>
-            </a:r>
-          </a:p>
-          <a:p>
-            <a:r>
-              <a:t>Trainer-Hinweis: Musterlösung im AB-3 Trainer-Abschnitt unten. Diskussionshinweis: Bei einigen Schritten gibt es Überschneidungen – das ist gewollt und soll zeigen, dass Teamarbeit wichtig ist.</a:t>
-            </a:r>
-          </a:p>
-          <a:p>
-            <a:r>
-              <a:t>AB-3 Musterlösung (Trainer-Version)</a:t>
-            </a:r>
-          </a:p>
-          <a:p>
-            <a:r>
-              <a:t>Lesart: X = federführend · (X) = beteiligt, aber nicht federführend.</a:t>
-            </a:r>
-          </a:p>
-          <a:p>
-            <a:r>
-              <a:t>Trainer-Hinweis: Die Praxis der Kreditantragserstellung variiert zwischen den Häusern. In einigen VR-Banken nimmt die Assistenz die Ersterfassung im agree-Kreditantragsmodul vor, der Berater prüft und votiert. Klären Sie im Onboarding-Gespräch, welcher Standard im eigenen Haus gilt – die Musterlösung zeigt die typische, nicht die einzig mögliche Aufteilung.</a:t>
-            </a:r>
-          </a:p>
-          <a:p>
-            <a:r>
-              <a:t>Trainer-Hinweis: Musterlösung im AB-4 Trainer-Abschnitt unten.</a:t>
-            </a:r>
-          </a:p>
-          <a:p>
-            <a:r>
-              <a:t>AB-4 Musterlösung (Trainer-Version)</a:t>
+              <a:t>Kernbotschaft: „Sie müssen wissen, was es gibt und wo Sie sich einordnen." Bei Unsicherheit, ob eine Aufgabe Markt oder Marktfolge zufällt, die Regel nutzen: das Votum ist immer Marktfolge.</a:t>
             </a:r>
           </a:p>
         </p:txBody>
@@ -825,7 +797,297 @@
           <a:lstStyle/>
           <a:p>
             <a:r>
-              <a:t>Siehe Trainerhandbuch (Sektion 3) für Moderationshinweise, Timing und erwartete Teilnehmerreaktionen.</a:t>
+              <a:t>Zuordnungslogik: agree = Kernsystem für Kundendaten, VR-NetWorld = Kunde bedient selbst. Bankgeheimnis/DSGVO als Grundregel ab Tag 1 verankern.</a:t>
+            </a:r>
+          </a:p>
+        </p:txBody>
+      </p:sp>
+      <p:sp>
+        <p:nvSpPr>
+          <p:cNvPr id="4" name="Slide Number Placeholder 3"/>
+          <p:cNvSpPr>
+            <a:spLocks noGrp="1"/>
+          </p:cNvSpPr>
+          <p:nvPr>
+            <p:ph type="sldNum" idx="5" sz="quarter"/>
+          </p:nvPr>
+        </p:nvSpPr>
+        <p:spPr/>
+      </p:sp>
+    </p:spTree>
+  </p:cSld>
+  <p:clrMapOvr>
+    <a:masterClrMapping/>
+  </p:clrMapOvr>
+</p:notes>
+</file>
+
+<file path=ppt/notesSlides/notesSlide6.xml><?xml version="1.0" encoding="utf-8"?>
+<p:notes xmlns:a="http://schemas.openxmlformats.org/drawingml/2006/main" xmlns:p="http://schemas.openxmlformats.org/presentationml/2006/main" xmlns:r="http://schemas.openxmlformats.org/officeDocument/2006/relationships">
+  <p:cSld>
+    <p:spTree>
+      <p:nvGrpSpPr>
+        <p:cNvPr id="1" name=""/>
+        <p:cNvGrpSpPr/>
+        <p:nvPr/>
+      </p:nvGrpSpPr>
+      <p:grpSpPr>
+        <a:xfrm>
+          <a:off x="0" y="0"/>
+          <a:ext cx="0" cy="0"/>
+          <a:chOff x="0" y="0"/>
+          <a:chExt cx="0" cy="0"/>
+        </a:xfrm>
+      </p:grpSpPr>
+      <p:sp>
+        <p:nvSpPr>
+          <p:cNvPr id="2" name="Slide Image Placeholder 1"/>
+          <p:cNvSpPr>
+            <a:spLocks noGrp="1"/>
+          </p:cNvSpPr>
+          <p:nvPr>
+            <p:ph type="sldImg" idx="2"/>
+          </p:nvPr>
+        </p:nvSpPr>
+        <p:spPr/>
+      </p:sp>
+      <p:sp>
+        <p:nvSpPr>
+          <p:cNvPr id="3" name="Notes Placeholder 2"/>
+          <p:cNvSpPr>
+            <a:spLocks noGrp="1"/>
+          </p:cNvSpPr>
+          <p:nvPr>
+            <p:ph type="body" idx="3" sz="quarter"/>
+          </p:nvPr>
+        </p:nvSpPr>
+        <p:spPr/>
+        <p:txBody>
+          <a:bodyPr/>
+          <a:lstStyle/>
+          <a:p>
+            <a:r>
+              <a:t>Die Landkarte ist kein Prüfstoff, sondern ein Orientierungswerkzeug. Aus Nachfragen wird mit der Zeit eigenständiges Handeln.</a:t>
+            </a:r>
+          </a:p>
+        </p:txBody>
+      </p:sp>
+      <p:sp>
+        <p:nvSpPr>
+          <p:cNvPr id="4" name="Slide Number Placeholder 3"/>
+          <p:cNvSpPr>
+            <a:spLocks noGrp="1"/>
+          </p:cNvSpPr>
+          <p:nvPr>
+            <p:ph type="sldNum" idx="5" sz="quarter"/>
+          </p:nvPr>
+        </p:nvSpPr>
+        <p:spPr/>
+      </p:sp>
+    </p:spTree>
+  </p:cSld>
+  <p:clrMapOvr>
+    <a:masterClrMapping/>
+  </p:clrMapOvr>
+</p:notes>
+</file>
+
+<file path=ppt/notesSlides/notesSlide7.xml><?xml version="1.0" encoding="utf-8"?>
+<p:notes xmlns:a="http://schemas.openxmlformats.org/drawingml/2006/main" xmlns:p="http://schemas.openxmlformats.org/presentationml/2006/main" xmlns:r="http://schemas.openxmlformats.org/officeDocument/2006/relationships">
+  <p:cSld>
+    <p:spTree>
+      <p:nvGrpSpPr>
+        <p:cNvPr id="1" name=""/>
+        <p:cNvGrpSpPr/>
+        <p:nvPr/>
+      </p:nvGrpSpPr>
+      <p:grpSpPr>
+        <a:xfrm>
+          <a:off x="0" y="0"/>
+          <a:ext cx="0" cy="0"/>
+          <a:chOff x="0" y="0"/>
+          <a:chExt cx="0" cy="0"/>
+        </a:xfrm>
+      </p:grpSpPr>
+      <p:sp>
+        <p:nvSpPr>
+          <p:cNvPr id="2" name="Slide Image Placeholder 1"/>
+          <p:cNvSpPr>
+            <a:spLocks noGrp="1"/>
+          </p:cNvSpPr>
+          <p:nvPr>
+            <p:ph type="sldImg" idx="2"/>
+          </p:nvPr>
+        </p:nvSpPr>
+        <p:spPr/>
+      </p:sp>
+      <p:sp>
+        <p:nvSpPr>
+          <p:cNvPr id="3" name="Notes Placeholder 2"/>
+          <p:cNvSpPr>
+            <a:spLocks noGrp="1"/>
+          </p:cNvSpPr>
+          <p:nvPr>
+            <p:ph type="body" idx="3" sz="quarter"/>
+          </p:nvPr>
+        </p:nvSpPr>
+        <p:spPr/>
+        <p:txBody>
+          <a:bodyPr/>
+          <a:lstStyle/>
+          <a:p>
+            <a:r>
+              <a:t>AB-3/AB-4 Musterlösung (Trainer-Version)</a:t>
+            </a:r>
+          </a:p>
+          <a:p>
+            <a:r>
+              <a:t>Kernpunkte: Votum = immer Marktfolge; agree = Kernsystem für Kundendaten; VR-NetWorld = Kundenportal, kein Innendienst-Zugang.</a:t>
+            </a:r>
+          </a:p>
+          <a:p>
+            <a:r>
+              <a:t>Trainer-Hinweis: erfahrene TN AB-5 als Multiplikator-Instrument rahmen („Was gäben Sie einer neuen Kollegin als Erstes in die Hand?").</a:t>
+            </a:r>
+          </a:p>
+        </p:txBody>
+      </p:sp>
+      <p:sp>
+        <p:nvSpPr>
+          <p:cNvPr id="4" name="Slide Number Placeholder 3"/>
+          <p:cNvSpPr>
+            <a:spLocks noGrp="1"/>
+          </p:cNvSpPr>
+          <p:nvPr>
+            <p:ph type="sldNum" idx="5" sz="quarter"/>
+          </p:nvPr>
+        </p:nvSpPr>
+        <p:spPr/>
+      </p:sp>
+    </p:spTree>
+  </p:cSld>
+  <p:clrMapOvr>
+    <a:masterClrMapping/>
+  </p:clrMapOvr>
+</p:notes>
+</file>
+
+<file path=ppt/notesSlides/notesSlide8.xml><?xml version="1.0" encoding="utf-8"?>
+<p:notes xmlns:a="http://schemas.openxmlformats.org/drawingml/2006/main" xmlns:p="http://schemas.openxmlformats.org/presentationml/2006/main" xmlns:r="http://schemas.openxmlformats.org/officeDocument/2006/relationships">
+  <p:cSld>
+    <p:spTree>
+      <p:nvGrpSpPr>
+        <p:cNvPr id="1" name=""/>
+        <p:cNvGrpSpPr/>
+        <p:nvPr/>
+      </p:nvGrpSpPr>
+      <p:grpSpPr>
+        <a:xfrm>
+          <a:off x="0" y="0"/>
+          <a:ext cx="0" cy="0"/>
+          <a:chOff x="0" y="0"/>
+          <a:chExt cx="0" cy="0"/>
+        </a:xfrm>
+      </p:grpSpPr>
+      <p:sp>
+        <p:nvSpPr>
+          <p:cNvPr id="2" name="Slide Image Placeholder 1"/>
+          <p:cNvSpPr>
+            <a:spLocks noGrp="1"/>
+          </p:cNvSpPr>
+          <p:nvPr>
+            <p:ph type="sldImg" idx="2"/>
+          </p:nvPr>
+        </p:nvSpPr>
+        <p:spPr/>
+      </p:sp>
+      <p:sp>
+        <p:nvSpPr>
+          <p:cNvPr id="3" name="Notes Placeholder 2"/>
+          <p:cNvSpPr>
+            <a:spLocks noGrp="1"/>
+          </p:cNvSpPr>
+          <p:nvPr>
+            <p:ph type="body" idx="3" sz="quarter"/>
+          </p:nvPr>
+        </p:nvSpPr>
+        <p:spPr/>
+        <p:txBody>
+          <a:bodyPr/>
+          <a:lstStyle/>
+          <a:p>
+            <a:r>
+              <a:t>Transferaufgabe (Sec 5): drei Fragen mit dem Berater klären, um AB-5 abzuschließen. Ausblick: VA03 (agree), VA01 (Kreditakte), VA08 (Selbstorganisation).</a:t>
+            </a:r>
+          </a:p>
+        </p:txBody>
+      </p:sp>
+      <p:sp>
+        <p:nvSpPr>
+          <p:cNvPr id="4" name="Slide Number Placeholder 3"/>
+          <p:cNvSpPr>
+            <a:spLocks noGrp="1"/>
+          </p:cNvSpPr>
+          <p:nvPr>
+            <p:ph type="sldNum" idx="5" sz="quarter"/>
+          </p:nvPr>
+        </p:nvSpPr>
+        <p:spPr/>
+      </p:sp>
+    </p:spTree>
+  </p:cSld>
+  <p:clrMapOvr>
+    <a:masterClrMapping/>
+  </p:clrMapOvr>
+</p:notes>
+</file>
+
+<file path=ppt/notesSlides/notesSlide9.xml><?xml version="1.0" encoding="utf-8"?>
+<p:notes xmlns:a="http://schemas.openxmlformats.org/drawingml/2006/main" xmlns:p="http://schemas.openxmlformats.org/presentationml/2006/main" xmlns:r="http://schemas.openxmlformats.org/officeDocument/2006/relationships">
+  <p:cSld>
+    <p:spTree>
+      <p:nvGrpSpPr>
+        <p:cNvPr id="1" name=""/>
+        <p:cNvGrpSpPr/>
+        <p:nvPr/>
+      </p:nvGrpSpPr>
+      <p:grpSpPr>
+        <a:xfrm>
+          <a:off x="0" y="0"/>
+          <a:ext cx="0" cy="0"/>
+          <a:chOff x="0" y="0"/>
+          <a:chExt cx="0" cy="0"/>
+        </a:xfrm>
+      </p:grpSpPr>
+      <p:sp>
+        <p:nvSpPr>
+          <p:cNvPr id="2" name="Slide Image Placeholder 1"/>
+          <p:cNvSpPr>
+            <a:spLocks noGrp="1"/>
+          </p:cNvSpPr>
+          <p:nvPr>
+            <p:ph type="sldImg" idx="2"/>
+          </p:nvPr>
+        </p:nvSpPr>
+        <p:spPr/>
+      </p:sp>
+      <p:sp>
+        <p:nvSpPr>
+          <p:cNvPr id="3" name="Notes Placeholder 2"/>
+          <p:cNvSpPr>
+            <a:spLocks noGrp="1"/>
+          </p:cNvSpPr>
+          <p:nvPr>
+            <p:ph type="body" idx="3" sz="quarter"/>
+          </p:nvPr>
+        </p:nvSpPr>
+        <p:spPr/>
+        <p:txBody>
+          <a:bodyPr/>
+          <a:lstStyle/>
+          <a:p>
+            <a:r>
+              <a:t>Moderationskarten grün/orange als Abschluss-Sammelrunde. Zwei Reflexionsfragen im Plenum (Empfehlung 1 und 3).</a:t>
             </a:r>
           </a:p>
         </p:txBody>
@@ -4396,6 +4658,2829 @@
 </p:sld>
 </file>
 
+<file path=ppt/slides/slide10.xml><?xml version="1.0" encoding="utf-8"?>
+<p:sld xmlns:a="http://schemas.openxmlformats.org/drawingml/2006/main" xmlns:p="http://schemas.openxmlformats.org/presentationml/2006/main" xmlns:r="http://schemas.openxmlformats.org/officeDocument/2006/relationships">
+  <p:cSld>
+    <p:spTree>
+      <p:nvGrpSpPr>
+        <p:cNvPr id="1" name=""/>
+        <p:cNvGrpSpPr/>
+        <p:nvPr/>
+      </p:nvGrpSpPr>
+      <p:grpSpPr/>
+      <p:sp>
+        <p:nvSpPr>
+          <p:cNvPr id="2" name="Rectangle 1"/>
+          <p:cNvSpPr/>
+          <p:nvPr/>
+        </p:nvSpPr>
+        <p:spPr>
+          <a:xfrm>
+            <a:off x="0" y="0"/>
+            <a:ext cx="12188952" cy="6858000"/>
+          </a:xfrm>
+          <a:prstGeom prst="rect">
+            <a:avLst/>
+          </a:prstGeom>
+          <a:solidFill>
+            <a:srgbClr val="FFFFFF"/>
+          </a:solidFill>
+          <a:ln>
+            <a:noFill/>
+          </a:ln>
+        </p:spPr>
+        <p:style>
+          <a:lnRef idx="1">
+            <a:schemeClr val="accent1"/>
+          </a:lnRef>
+          <a:fillRef idx="3">
+            <a:schemeClr val="accent1"/>
+          </a:fillRef>
+          <a:effectRef idx="2">
+            <a:schemeClr val="accent1"/>
+          </a:effectRef>
+          <a:fontRef idx="minor">
+            <a:schemeClr val="lt1"/>
+          </a:fontRef>
+        </p:style>
+        <p:txBody>
+          <a:bodyPr rtlCol="0" anchor="ctr"/>
+          <a:lstStyle/>
+          <a:p>
+            <a:pPr algn="ctr"/>
+          </a:p>
+        </p:txBody>
+      </p:sp>
+      <p:sp>
+        <p:nvSpPr>
+          <p:cNvPr id="3" name="Rectangle 2"/>
+          <p:cNvSpPr/>
+          <p:nvPr/>
+        </p:nvSpPr>
+        <p:spPr>
+          <a:xfrm>
+            <a:off x="0" y="0"/>
+            <a:ext cx="12188952" cy="50292"/>
+          </a:xfrm>
+          <a:prstGeom prst="rect">
+            <a:avLst/>
+          </a:prstGeom>
+          <a:solidFill>
+            <a:srgbClr val="1F2C56"/>
+          </a:solidFill>
+          <a:ln>
+            <a:noFill/>
+          </a:ln>
+        </p:spPr>
+        <p:style>
+          <a:lnRef idx="1">
+            <a:schemeClr val="accent1"/>
+          </a:lnRef>
+          <a:fillRef idx="3">
+            <a:schemeClr val="accent1"/>
+          </a:fillRef>
+          <a:effectRef idx="2">
+            <a:schemeClr val="accent1"/>
+          </a:effectRef>
+          <a:fontRef idx="minor">
+            <a:schemeClr val="lt1"/>
+          </a:fontRef>
+        </p:style>
+        <p:txBody>
+          <a:bodyPr rtlCol="0" anchor="ctr"/>
+          <a:lstStyle/>
+          <a:p>
+            <a:pPr algn="ctr"/>
+          </a:p>
+        </p:txBody>
+      </p:sp>
+      <p:sp>
+        <p:nvSpPr>
+          <p:cNvPr id="4" name="TextBox 3"/>
+          <p:cNvSpPr txBox="1"/>
+          <p:nvPr/>
+        </p:nvSpPr>
+        <p:spPr>
+          <a:xfrm>
+            <a:off x="685800" y="109728"/>
+            <a:ext cx="10817352" cy="228600"/>
+          </a:xfrm>
+          <a:prstGeom prst="rect">
+            <a:avLst/>
+          </a:prstGeom>
+          <a:noFill/>
+        </p:spPr>
+        <p:txBody>
+          <a:bodyPr wrap="none">
+            <a:spAutoFit/>
+          </a:bodyPr>
+          <a:lstStyle/>
+          <a:p>
+            <a:pPr algn="l"/>
+            <a:r>
+              <a:rPr sz="750">
+                <a:solidFill>
+                  <a:srgbClr val="78808C"/>
+                </a:solidFill>
+                <a:latin typeface="Consolas"/>
+              </a:rPr>
+              <a:t>VA00  ·  SCHAUBILD</a:t>
+            </a:r>
+          </a:p>
+        </p:txBody>
+      </p:sp>
+      <p:sp>
+        <p:nvSpPr>
+          <p:cNvPr id="5" name="TextBox 4"/>
+          <p:cNvSpPr txBox="1"/>
+          <p:nvPr/>
+        </p:nvSpPr>
+        <p:spPr>
+          <a:xfrm>
+            <a:off x="685800" y="502920"/>
+            <a:ext cx="10817352" cy="594360"/>
+          </a:xfrm>
+          <a:prstGeom prst="rect">
+            <a:avLst/>
+          </a:prstGeom>
+          <a:noFill/>
+        </p:spPr>
+        <p:txBody>
+          <a:bodyPr wrap="square">
+            <a:spAutoFit/>
+          </a:bodyPr>
+          <a:lstStyle/>
+          <a:p>
+            <a:pPr algn="l"/>
+            <a:r>
+              <a:rPr sz="2000" b="1" i="0">
+                <a:solidFill>
+                  <a:srgbClr val="1F2C56"/>
+                </a:solidFill>
+                <a:latin typeface="Arial"/>
+              </a:rPr>
+              <a:t>Der Kreditprozess end-to-end</a:t>
+            </a:r>
+          </a:p>
+        </p:txBody>
+      </p:sp>
+      <p:sp>
+        <p:nvSpPr>
+          <p:cNvPr id="6" name="Rectangle 5"/>
+          <p:cNvSpPr/>
+          <p:nvPr/>
+        </p:nvSpPr>
+        <p:spPr>
+          <a:xfrm>
+            <a:off x="685800" y="1143000"/>
+            <a:ext cx="10817352" cy="25400"/>
+          </a:xfrm>
+          <a:prstGeom prst="rect">
+            <a:avLst/>
+          </a:prstGeom>
+          <a:solidFill>
+            <a:srgbClr val="D9C089"/>
+          </a:solidFill>
+          <a:ln>
+            <a:noFill/>
+          </a:ln>
+        </p:spPr>
+        <p:style>
+          <a:lnRef idx="1">
+            <a:schemeClr val="accent1"/>
+          </a:lnRef>
+          <a:fillRef idx="3">
+            <a:schemeClr val="accent1"/>
+          </a:fillRef>
+          <a:effectRef idx="2">
+            <a:schemeClr val="accent1"/>
+          </a:effectRef>
+          <a:fontRef idx="minor">
+            <a:schemeClr val="lt1"/>
+          </a:fontRef>
+        </p:style>
+        <p:txBody>
+          <a:bodyPr rtlCol="0" anchor="ctr"/>
+          <a:lstStyle/>
+          <a:p>
+            <a:pPr algn="ctr"/>
+          </a:p>
+        </p:txBody>
+      </p:sp>
+      <p:pic>
+        <p:nvPicPr>
+          <p:cNvPr id="7" name="Picture 6" descr="image.png"/>
+          <p:cNvPicPr>
+            <a:picLocks noChangeAspect="1"/>
+          </p:cNvPicPr>
+          <p:nvPr/>
+        </p:nvPicPr>
+        <p:blipFill>
+          <a:blip r:embed="rId2"/>
+          <a:stretch>
+            <a:fillRect/>
+          </a:stretch>
+        </p:blipFill>
+        <p:spPr>
+          <a:xfrm>
+            <a:off x="2303489" y="1325880"/>
+            <a:ext cx="7581973" cy="4937760"/>
+          </a:xfrm>
+          <a:prstGeom prst="rect">
+            <a:avLst/>
+          </a:prstGeom>
+        </p:spPr>
+      </p:pic>
+      <p:sp>
+        <p:nvSpPr>
+          <p:cNvPr id="8" name="Rectangle 7"/>
+          <p:cNvSpPr/>
+          <p:nvPr/>
+        </p:nvSpPr>
+        <p:spPr>
+          <a:xfrm>
+            <a:off x="0" y="6510528"/>
+            <a:ext cx="12188952" cy="347472"/>
+          </a:xfrm>
+          <a:prstGeom prst="rect">
+            <a:avLst/>
+          </a:prstGeom>
+          <a:solidFill>
+            <a:srgbClr val="0A1937"/>
+          </a:solidFill>
+          <a:ln>
+            <a:noFill/>
+          </a:ln>
+        </p:spPr>
+        <p:style>
+          <a:lnRef idx="1">
+            <a:schemeClr val="accent1"/>
+          </a:lnRef>
+          <a:fillRef idx="3">
+            <a:schemeClr val="accent1"/>
+          </a:fillRef>
+          <a:effectRef idx="2">
+            <a:schemeClr val="accent1"/>
+          </a:effectRef>
+          <a:fontRef idx="minor">
+            <a:schemeClr val="lt1"/>
+          </a:fontRef>
+        </p:style>
+        <p:txBody>
+          <a:bodyPr rtlCol="0" anchor="ctr"/>
+          <a:lstStyle/>
+          <a:p>
+            <a:pPr algn="ctr"/>
+          </a:p>
+        </p:txBody>
+      </p:sp>
+      <p:sp>
+        <p:nvSpPr>
+          <p:cNvPr id="9" name="TextBox 8"/>
+          <p:cNvSpPr txBox="1"/>
+          <p:nvPr/>
+        </p:nvSpPr>
+        <p:spPr>
+          <a:xfrm>
+            <a:off x="685800" y="6583680"/>
+            <a:ext cx="6490411" cy="256032"/>
+          </a:xfrm>
+          <a:prstGeom prst="rect">
+            <a:avLst/>
+          </a:prstGeom>
+          <a:noFill/>
+        </p:spPr>
+        <p:txBody>
+          <a:bodyPr wrap="none">
+            <a:spAutoFit/>
+          </a:bodyPr>
+          <a:lstStyle/>
+          <a:p>
+            <a:pPr algn="l"/>
+            <a:r>
+              <a:rPr sz="700">
+                <a:solidFill>
+                  <a:srgbClr val="A0B4D2"/>
+                </a:solidFill>
+                <a:latin typeface="Consolas"/>
+              </a:rPr>
+              <a:t>FKB Campus  ·  VA00</a:t>
+            </a:r>
+          </a:p>
+        </p:txBody>
+      </p:sp>
+      <p:sp>
+        <p:nvSpPr>
+          <p:cNvPr id="10" name="TextBox 9"/>
+          <p:cNvSpPr txBox="1"/>
+          <p:nvPr/>
+        </p:nvSpPr>
+        <p:spPr>
+          <a:xfrm>
+            <a:off x="7176211" y="6583680"/>
+            <a:ext cx="4326940" cy="256032"/>
+          </a:xfrm>
+          <a:prstGeom prst="rect">
+            <a:avLst/>
+          </a:prstGeom>
+          <a:noFill/>
+        </p:spPr>
+        <p:txBody>
+          <a:bodyPr wrap="none">
+            <a:spAutoFit/>
+          </a:bodyPr>
+          <a:lstStyle/>
+          <a:p>
+            <a:pPr algn="r"/>
+            <a:r>
+              <a:rPr sz="700">
+                <a:solidFill>
+                  <a:srgbClr val="A0B4D2"/>
+                </a:solidFill>
+                <a:latin typeface="Consolas"/>
+              </a:rPr>
+              <a:t>Schaubild</a:t>
+            </a:r>
+          </a:p>
+        </p:txBody>
+      </p:sp>
+    </p:spTree>
+  </p:cSld>
+  <p:clrMapOvr>
+    <a:masterClrMapping/>
+  </p:clrMapOvr>
+</p:sld>
+</file>
+
+<file path=ppt/slides/slide11.xml><?xml version="1.0" encoding="utf-8"?>
+<p:sld xmlns:a="http://schemas.openxmlformats.org/drawingml/2006/main" xmlns:p="http://schemas.openxmlformats.org/presentationml/2006/main" xmlns:r="http://schemas.openxmlformats.org/officeDocument/2006/relationships">
+  <p:cSld>
+    <p:spTree>
+      <p:nvGrpSpPr>
+        <p:cNvPr id="1" name=""/>
+        <p:cNvGrpSpPr/>
+        <p:nvPr/>
+      </p:nvGrpSpPr>
+      <p:grpSpPr/>
+      <p:sp>
+        <p:nvSpPr>
+          <p:cNvPr id="2" name="Rectangle 1"/>
+          <p:cNvSpPr/>
+          <p:nvPr/>
+        </p:nvSpPr>
+        <p:spPr>
+          <a:xfrm>
+            <a:off x="0" y="0"/>
+            <a:ext cx="12188952" cy="6858000"/>
+          </a:xfrm>
+          <a:prstGeom prst="rect">
+            <a:avLst/>
+          </a:prstGeom>
+          <a:solidFill>
+            <a:srgbClr val="1F2C56"/>
+          </a:solidFill>
+          <a:ln>
+            <a:noFill/>
+          </a:ln>
+        </p:spPr>
+        <p:style>
+          <a:lnRef idx="1">
+            <a:schemeClr val="accent1"/>
+          </a:lnRef>
+          <a:fillRef idx="3">
+            <a:schemeClr val="accent1"/>
+          </a:fillRef>
+          <a:effectRef idx="2">
+            <a:schemeClr val="accent1"/>
+          </a:effectRef>
+          <a:fontRef idx="minor">
+            <a:schemeClr val="lt1"/>
+          </a:fontRef>
+        </p:style>
+        <p:txBody>
+          <a:bodyPr rtlCol="0" anchor="ctr"/>
+          <a:lstStyle/>
+          <a:p>
+            <a:pPr algn="ctr"/>
+          </a:p>
+        </p:txBody>
+      </p:sp>
+      <p:sp>
+        <p:nvSpPr>
+          <p:cNvPr id="3" name="TextBox 2"/>
+          <p:cNvSpPr txBox="1"/>
+          <p:nvPr/>
+        </p:nvSpPr>
+        <p:spPr>
+          <a:xfrm>
+            <a:off x="685800" y="2377440"/>
+            <a:ext cx="10817352" cy="365760"/>
+          </a:xfrm>
+          <a:prstGeom prst="rect">
+            <a:avLst/>
+          </a:prstGeom>
+          <a:noFill/>
+        </p:spPr>
+        <p:txBody>
+          <a:bodyPr wrap="none">
+            <a:spAutoFit/>
+          </a:bodyPr>
+          <a:lstStyle/>
+          <a:p>
+            <a:pPr algn="l"/>
+            <a:r>
+              <a:rPr sz="1200">
+                <a:solidFill>
+                  <a:srgbClr val="D9C089"/>
+                </a:solidFill>
+                <a:latin typeface="Consolas"/>
+              </a:rPr>
+              <a:t>00:40–00:50</a:t>
+            </a:r>
+          </a:p>
+        </p:txBody>
+      </p:sp>
+      <p:sp>
+        <p:nvSpPr>
+          <p:cNvPr id="4" name="Rectangle 3"/>
+          <p:cNvSpPr/>
+          <p:nvPr/>
+        </p:nvSpPr>
+        <p:spPr>
+          <a:xfrm>
+            <a:off x="685800" y="2788920"/>
+            <a:ext cx="548640" cy="38100"/>
+          </a:xfrm>
+          <a:prstGeom prst="rect">
+            <a:avLst/>
+          </a:prstGeom>
+          <a:solidFill>
+            <a:srgbClr val="D9C089"/>
+          </a:solidFill>
+          <a:ln>
+            <a:noFill/>
+          </a:ln>
+        </p:spPr>
+        <p:style>
+          <a:lnRef idx="1">
+            <a:schemeClr val="accent1"/>
+          </a:lnRef>
+          <a:fillRef idx="3">
+            <a:schemeClr val="accent1"/>
+          </a:fillRef>
+          <a:effectRef idx="2">
+            <a:schemeClr val="accent1"/>
+          </a:effectRef>
+          <a:fontRef idx="minor">
+            <a:schemeClr val="lt1"/>
+          </a:fontRef>
+        </p:style>
+        <p:txBody>
+          <a:bodyPr rtlCol="0" anchor="ctr"/>
+          <a:lstStyle/>
+          <a:p>
+            <a:pPr algn="ctr"/>
+          </a:p>
+        </p:txBody>
+      </p:sp>
+      <p:sp>
+        <p:nvSpPr>
+          <p:cNvPr id="5" name="TextBox 4"/>
+          <p:cNvSpPr txBox="1"/>
+          <p:nvPr/>
+        </p:nvSpPr>
+        <p:spPr>
+          <a:xfrm>
+            <a:off x="685800" y="3017520"/>
+            <a:ext cx="10817352" cy="1463040"/>
+          </a:xfrm>
+          <a:prstGeom prst="rect">
+            <a:avLst/>
+          </a:prstGeom>
+          <a:noFill/>
+        </p:spPr>
+        <p:txBody>
+          <a:bodyPr wrap="square">
+            <a:spAutoFit/>
+          </a:bodyPr>
+          <a:lstStyle/>
+          <a:p>
+            <a:pPr algn="l"/>
+            <a:r>
+              <a:rPr sz="4000" b="1" i="0">
+                <a:solidFill>
+                  <a:srgbClr val="FFFFFF"/>
+                </a:solidFill>
+                <a:latin typeface="Arial"/>
+              </a:rPr>
+              <a:t>Feld 3 &amp; 4</a:t>
+            </a:r>
+          </a:p>
+        </p:txBody>
+      </p:sp>
+      <p:sp>
+        <p:nvSpPr>
+          <p:cNvPr id="6" name="TextBox 5"/>
+          <p:cNvSpPr txBox="1"/>
+          <p:nvPr/>
+        </p:nvSpPr>
+        <p:spPr>
+          <a:xfrm>
+            <a:off x="685800" y="4480560"/>
+            <a:ext cx="8653881" cy="1280160"/>
+          </a:xfrm>
+          <a:prstGeom prst="rect">
+            <a:avLst/>
+          </a:prstGeom>
+          <a:noFill/>
+        </p:spPr>
+        <p:txBody>
+          <a:bodyPr wrap="square">
+            <a:spAutoFit/>
+          </a:bodyPr>
+          <a:lstStyle/>
+          <a:p>
+            <a:pPr algn="l"/>
+            <a:r>
+              <a:rPr sz="1600" b="0" i="0">
+                <a:solidFill>
+                  <a:srgbClr val="C8D2E6"/>
+                </a:solidFill>
+                <a:latin typeface="Arial"/>
+              </a:rPr>
+              <a:t>Die Systemlandschaft und die Erwartungen der Berater kennen.</a:t>
+            </a:r>
+          </a:p>
+        </p:txBody>
+      </p:sp>
+      <p:sp>
+        <p:nvSpPr>
+          <p:cNvPr id="7" name="TextBox 6"/>
+          <p:cNvSpPr txBox="1"/>
+          <p:nvPr/>
+        </p:nvSpPr>
+        <p:spPr>
+          <a:xfrm>
+            <a:off x="685800" y="6355080"/>
+            <a:ext cx="10817352" cy="274320"/>
+          </a:xfrm>
+          <a:prstGeom prst="rect">
+            <a:avLst/>
+          </a:prstGeom>
+          <a:noFill/>
+        </p:spPr>
+        <p:txBody>
+          <a:bodyPr wrap="none">
+            <a:spAutoFit/>
+          </a:bodyPr>
+          <a:lstStyle/>
+          <a:p>
+            <a:pPr algn="l"/>
+            <a:r>
+              <a:rPr sz="700">
+                <a:solidFill>
+                  <a:srgbClr val="8CA0C3"/>
+                </a:solidFill>
+                <a:latin typeface="Consolas"/>
+              </a:rPr>
+              <a:t>FKB Campus  ·  VA00</a:t>
+            </a:r>
+          </a:p>
+        </p:txBody>
+      </p:sp>
+    </p:spTree>
+  </p:cSld>
+  <p:clrMapOvr>
+    <a:masterClrMapping/>
+  </p:clrMapOvr>
+</p:sld>
+</file>
+
+<file path=ppt/slides/slide12.xml><?xml version="1.0" encoding="utf-8"?>
+<p:sld xmlns:a="http://schemas.openxmlformats.org/drawingml/2006/main" xmlns:p="http://schemas.openxmlformats.org/presentationml/2006/main" xmlns:r="http://schemas.openxmlformats.org/officeDocument/2006/relationships">
+  <p:cSld>
+    <p:spTree>
+      <p:nvGrpSpPr>
+        <p:cNvPr id="1" name=""/>
+        <p:cNvGrpSpPr/>
+        <p:nvPr/>
+      </p:nvGrpSpPr>
+      <p:grpSpPr/>
+      <p:sp>
+        <p:nvSpPr>
+          <p:cNvPr id="2" name="Rectangle 1"/>
+          <p:cNvSpPr/>
+          <p:nvPr/>
+        </p:nvSpPr>
+        <p:spPr>
+          <a:xfrm>
+            <a:off x="0" y="0"/>
+            <a:ext cx="12188952" cy="6858000"/>
+          </a:xfrm>
+          <a:prstGeom prst="rect">
+            <a:avLst/>
+          </a:prstGeom>
+          <a:solidFill>
+            <a:srgbClr val="EDEDF3"/>
+          </a:solidFill>
+          <a:ln>
+            <a:noFill/>
+          </a:ln>
+        </p:spPr>
+        <p:style>
+          <a:lnRef idx="1">
+            <a:schemeClr val="accent1"/>
+          </a:lnRef>
+          <a:fillRef idx="3">
+            <a:schemeClr val="accent1"/>
+          </a:fillRef>
+          <a:effectRef idx="2">
+            <a:schemeClr val="accent1"/>
+          </a:effectRef>
+          <a:fontRef idx="minor">
+            <a:schemeClr val="lt1"/>
+          </a:fontRef>
+        </p:style>
+        <p:txBody>
+          <a:bodyPr rtlCol="0" anchor="ctr"/>
+          <a:lstStyle/>
+          <a:p>
+            <a:pPr algn="ctr"/>
+          </a:p>
+        </p:txBody>
+      </p:sp>
+      <p:sp>
+        <p:nvSpPr>
+          <p:cNvPr id="3" name="Rectangle 2"/>
+          <p:cNvSpPr/>
+          <p:nvPr/>
+        </p:nvSpPr>
+        <p:spPr>
+          <a:xfrm>
+            <a:off x="0" y="0"/>
+            <a:ext cx="12188952" cy="50292"/>
+          </a:xfrm>
+          <a:prstGeom prst="rect">
+            <a:avLst/>
+          </a:prstGeom>
+          <a:solidFill>
+            <a:srgbClr val="1F2C56"/>
+          </a:solidFill>
+          <a:ln>
+            <a:noFill/>
+          </a:ln>
+        </p:spPr>
+        <p:style>
+          <a:lnRef idx="1">
+            <a:schemeClr val="accent1"/>
+          </a:lnRef>
+          <a:fillRef idx="3">
+            <a:schemeClr val="accent1"/>
+          </a:fillRef>
+          <a:effectRef idx="2">
+            <a:schemeClr val="accent1"/>
+          </a:effectRef>
+          <a:fontRef idx="minor">
+            <a:schemeClr val="lt1"/>
+          </a:fontRef>
+        </p:style>
+        <p:txBody>
+          <a:bodyPr rtlCol="0" anchor="ctr"/>
+          <a:lstStyle/>
+          <a:p>
+            <a:pPr algn="ctr"/>
+          </a:p>
+        </p:txBody>
+      </p:sp>
+      <p:sp>
+        <p:nvSpPr>
+          <p:cNvPr id="4" name="TextBox 3"/>
+          <p:cNvSpPr txBox="1"/>
+          <p:nvPr/>
+        </p:nvSpPr>
+        <p:spPr>
+          <a:xfrm>
+            <a:off x="685800" y="109728"/>
+            <a:ext cx="10817352" cy="228600"/>
+          </a:xfrm>
+          <a:prstGeom prst="rect">
+            <a:avLst/>
+          </a:prstGeom>
+          <a:noFill/>
+        </p:spPr>
+        <p:txBody>
+          <a:bodyPr wrap="none">
+            <a:spAutoFit/>
+          </a:bodyPr>
+          <a:lstStyle/>
+          <a:p>
+            <a:pPr algn="l"/>
+            <a:r>
+              <a:rPr sz="750">
+                <a:solidFill>
+                  <a:srgbClr val="78808C"/>
+                </a:solidFill>
+                <a:latin typeface="Consolas"/>
+              </a:rPr>
+              <a:t>VA00  ·  INHALT</a:t>
+            </a:r>
+          </a:p>
+        </p:txBody>
+      </p:sp>
+      <p:sp>
+        <p:nvSpPr>
+          <p:cNvPr id="5" name="Rectangle 4"/>
+          <p:cNvSpPr/>
+          <p:nvPr/>
+        </p:nvSpPr>
+        <p:spPr>
+          <a:xfrm>
+            <a:off x="0" y="1234440"/>
+            <a:ext cx="12188952" cy="12700"/>
+          </a:xfrm>
+          <a:prstGeom prst="rect">
+            <a:avLst/>
+          </a:prstGeom>
+          <a:solidFill>
+            <a:srgbClr val="D8DFE4"/>
+          </a:solidFill>
+          <a:ln>
+            <a:noFill/>
+          </a:ln>
+        </p:spPr>
+        <p:style>
+          <a:lnRef idx="1">
+            <a:schemeClr val="accent1"/>
+          </a:lnRef>
+          <a:fillRef idx="3">
+            <a:schemeClr val="accent1"/>
+          </a:fillRef>
+          <a:effectRef idx="2">
+            <a:schemeClr val="accent1"/>
+          </a:effectRef>
+          <a:fontRef idx="minor">
+            <a:schemeClr val="lt1"/>
+          </a:fontRef>
+        </p:style>
+        <p:txBody>
+          <a:bodyPr rtlCol="0" anchor="ctr"/>
+          <a:lstStyle/>
+          <a:p>
+            <a:pPr algn="ctr"/>
+          </a:p>
+        </p:txBody>
+      </p:sp>
+      <p:sp>
+        <p:nvSpPr>
+          <p:cNvPr id="6" name="Rectangle 5"/>
+          <p:cNvSpPr/>
+          <p:nvPr/>
+        </p:nvSpPr>
+        <p:spPr>
+          <a:xfrm>
+            <a:off x="685800" y="502920"/>
+            <a:ext cx="36576" cy="658368"/>
+          </a:xfrm>
+          <a:prstGeom prst="rect">
+            <a:avLst/>
+          </a:prstGeom>
+          <a:solidFill>
+            <a:srgbClr val="D9C089"/>
+          </a:solidFill>
+          <a:ln>
+            <a:noFill/>
+          </a:ln>
+        </p:spPr>
+        <p:style>
+          <a:lnRef idx="1">
+            <a:schemeClr val="accent1"/>
+          </a:lnRef>
+          <a:fillRef idx="3">
+            <a:schemeClr val="accent1"/>
+          </a:fillRef>
+          <a:effectRef idx="2">
+            <a:schemeClr val="accent1"/>
+          </a:effectRef>
+          <a:fontRef idx="minor">
+            <a:schemeClr val="lt1"/>
+          </a:fontRef>
+        </p:style>
+        <p:txBody>
+          <a:bodyPr rtlCol="0" anchor="ctr"/>
+          <a:lstStyle/>
+          <a:p>
+            <a:pPr algn="ctr"/>
+          </a:p>
+        </p:txBody>
+      </p:sp>
+      <p:sp>
+        <p:nvSpPr>
+          <p:cNvPr id="7" name="TextBox 6"/>
+          <p:cNvSpPr txBox="1"/>
+          <p:nvPr/>
+        </p:nvSpPr>
+        <p:spPr>
+          <a:xfrm>
+            <a:off x="813816" y="502920"/>
+            <a:ext cx="10634472" cy="685800"/>
+          </a:xfrm>
+          <a:prstGeom prst="rect">
+            <a:avLst/>
+          </a:prstGeom>
+          <a:noFill/>
+        </p:spPr>
+        <p:txBody>
+          <a:bodyPr wrap="square">
+            <a:spAutoFit/>
+          </a:bodyPr>
+          <a:lstStyle/>
+          <a:p>
+            <a:pPr algn="l"/>
+            <a:r>
+              <a:rPr sz="2400" b="1" i="0">
+                <a:solidFill>
+                  <a:srgbClr val="1F2C56"/>
+                </a:solidFill>
+                <a:latin typeface="Arial"/>
+              </a:rPr>
+              <a:t>Systeme und Erwartungen</a:t>
+            </a:r>
+          </a:p>
+        </p:txBody>
+      </p:sp>
+      <p:sp>
+        <p:nvSpPr>
+          <p:cNvPr id="8" name="TextBox 7"/>
+          <p:cNvSpPr txBox="1"/>
+          <p:nvPr/>
+        </p:nvSpPr>
+        <p:spPr>
+          <a:xfrm>
+            <a:off x="685800" y="1417320"/>
+            <a:ext cx="10817352" cy="4892040"/>
+          </a:xfrm>
+          <a:prstGeom prst="rect">
+            <a:avLst/>
+          </a:prstGeom>
+          <a:noFill/>
+        </p:spPr>
+        <p:txBody>
+          <a:bodyPr wrap="square">
+            <a:spAutoFit/>
+          </a:bodyPr>
+          <a:lstStyle/>
+          <a:p>
+            <a:pPr marL="177800" indent="-177800">
+              <a:spcBef>
+                <a:spcPts val="600"/>
+              </a:spcBef>
+              <a:spcAft>
+                <a:spcPts val="200"/>
+              </a:spcAft>
+            </a:pPr>
+            <a:r>
+              <a:rPr sz="1200" i="1">
+                <a:solidFill>
+                  <a:srgbClr val="3D5466"/>
+                </a:solidFill>
+                <a:latin typeface="Arial"/>
+              </a:rPr>
+              <a:t>→  Kundendaten gehören ins System, nicht auf einen Zettel – Bankgeheimnis und DSGVO gelten ab Tag 1.</a:t>
+            </a:r>
+          </a:p>
+          <a:p>
+            <a:pPr>
+              <a:spcBef>
+                <a:spcPts val="1000"/>
+              </a:spcBef>
+              <a:spcAft>
+                <a:spcPts val="200"/>
+              </a:spcAft>
+            </a:pPr>
+            <a:r>
+              <a:rPr sz="800" b="1">
+                <a:solidFill>
+                  <a:srgbClr val="78808C"/>
+                </a:solidFill>
+                <a:latin typeface="Consolas"/>
+              </a:rPr>
+              <a:t>SYSTEMLANDSCHAFT</a:t>
+            </a:r>
+          </a:p>
+          <a:p>
+            <a:pPr marL="190500" indent="-190500">
+              <a:spcBef>
+                <a:spcPts val="400"/>
+              </a:spcBef>
+              <a:spcAft>
+                <a:spcPts val="200"/>
+              </a:spcAft>
+            </a:pPr>
+            <a:r>
+              <a:rPr sz="1300">
+                <a:solidFill>
+                  <a:srgbClr val="3D5466"/>
+                </a:solidFill>
+                <a:latin typeface="Arial"/>
+              </a:rPr>
+              <a:t>▸  agree = Kernbankverfahren (Kundenstamm, Engagements, Wiedervorlagen); DMS = digitale Ablage.</a:t>
+            </a:r>
+          </a:p>
+          <a:p>
+            <a:pPr marL="190500" indent="-190500">
+              <a:spcBef>
+                <a:spcPts val="400"/>
+              </a:spcBef>
+              <a:spcAft>
+                <a:spcPts val="200"/>
+              </a:spcAft>
+            </a:pPr>
+            <a:r>
+              <a:rPr sz="1300">
+                <a:solidFill>
+                  <a:srgbClr val="3D5466"/>
+                </a:solidFill>
+                <a:latin typeface="Arial"/>
+              </a:rPr>
+              <a:t>▸  M365 für Office/Kommunikation; VR-NetWorld ist das Kundenportal – kein Innendienst-Zugang.</a:t>
+            </a:r>
+          </a:p>
+          <a:p>
+            <a:pPr>
+              <a:spcBef>
+                <a:spcPts val="1000"/>
+              </a:spcBef>
+              <a:spcAft>
+                <a:spcPts val="200"/>
+              </a:spcAft>
+            </a:pPr>
+            <a:r>
+              <a:rPr sz="800" b="1">
+                <a:solidFill>
+                  <a:srgbClr val="78808C"/>
+                </a:solidFill>
+                <a:latin typeface="Consolas"/>
+              </a:rPr>
+              <a:t>ERWARTUNGEN &amp; SCHNITTSTELLEN</a:t>
+            </a:r>
+          </a:p>
+          <a:p>
+            <a:pPr marL="190500" indent="-190500">
+              <a:spcBef>
+                <a:spcPts val="400"/>
+              </a:spcBef>
+              <a:spcAft>
+                <a:spcPts val="200"/>
+              </a:spcAft>
+            </a:pPr>
+            <a:r>
+              <a:rPr sz="1300">
+                <a:solidFill>
+                  <a:srgbClr val="3D5466"/>
+                </a:solidFill>
+                <a:latin typeface="Arial"/>
+              </a:rPr>
+              <a:t>▸  Berater erwarten vollständige, aktuelle Zuarbeit; die richtige Stelle für jede Frage kennen.</a:t>
+            </a:r>
+          </a:p>
+        </p:txBody>
+      </p:sp>
+      <p:sp>
+        <p:nvSpPr>
+          <p:cNvPr id="9" name="Rectangle 8"/>
+          <p:cNvSpPr/>
+          <p:nvPr/>
+        </p:nvSpPr>
+        <p:spPr>
+          <a:xfrm>
+            <a:off x="0" y="6510528"/>
+            <a:ext cx="12188952" cy="347472"/>
+          </a:xfrm>
+          <a:prstGeom prst="rect">
+            <a:avLst/>
+          </a:prstGeom>
+          <a:solidFill>
+            <a:srgbClr val="0A1937"/>
+          </a:solidFill>
+          <a:ln>
+            <a:noFill/>
+          </a:ln>
+        </p:spPr>
+        <p:style>
+          <a:lnRef idx="1">
+            <a:schemeClr val="accent1"/>
+          </a:lnRef>
+          <a:fillRef idx="3">
+            <a:schemeClr val="accent1"/>
+          </a:fillRef>
+          <a:effectRef idx="2">
+            <a:schemeClr val="accent1"/>
+          </a:effectRef>
+          <a:fontRef idx="minor">
+            <a:schemeClr val="lt1"/>
+          </a:fontRef>
+        </p:style>
+        <p:txBody>
+          <a:bodyPr rtlCol="0" anchor="ctr"/>
+          <a:lstStyle/>
+          <a:p>
+            <a:pPr algn="ctr"/>
+          </a:p>
+        </p:txBody>
+      </p:sp>
+      <p:sp>
+        <p:nvSpPr>
+          <p:cNvPr id="10" name="TextBox 9"/>
+          <p:cNvSpPr txBox="1"/>
+          <p:nvPr/>
+        </p:nvSpPr>
+        <p:spPr>
+          <a:xfrm>
+            <a:off x="685800" y="6583680"/>
+            <a:ext cx="6490411" cy="256032"/>
+          </a:xfrm>
+          <a:prstGeom prst="rect">
+            <a:avLst/>
+          </a:prstGeom>
+          <a:noFill/>
+        </p:spPr>
+        <p:txBody>
+          <a:bodyPr wrap="none">
+            <a:spAutoFit/>
+          </a:bodyPr>
+          <a:lstStyle/>
+          <a:p>
+            <a:pPr algn="l"/>
+            <a:r>
+              <a:rPr sz="700">
+                <a:solidFill>
+                  <a:srgbClr val="A0B4D2"/>
+                </a:solidFill>
+                <a:latin typeface="Consolas"/>
+              </a:rPr>
+              <a:t>FKB Campus  ·  VA00</a:t>
+            </a:r>
+          </a:p>
+        </p:txBody>
+      </p:sp>
+    </p:spTree>
+  </p:cSld>
+  <p:clrMapOvr>
+    <a:masterClrMapping/>
+  </p:clrMapOvr>
+</p:sld>
+</file>
+
+<file path=ppt/slides/slide13.xml><?xml version="1.0" encoding="utf-8"?>
+<p:sld xmlns:a="http://schemas.openxmlformats.org/drawingml/2006/main" xmlns:p="http://schemas.openxmlformats.org/presentationml/2006/main" xmlns:r="http://schemas.openxmlformats.org/officeDocument/2006/relationships">
+  <p:cSld>
+    <p:spTree>
+      <p:nvGrpSpPr>
+        <p:cNvPr id="1" name=""/>
+        <p:cNvGrpSpPr/>
+        <p:nvPr/>
+      </p:nvGrpSpPr>
+      <p:grpSpPr/>
+      <p:sp>
+        <p:nvSpPr>
+          <p:cNvPr id="2" name="Rectangle 1"/>
+          <p:cNvSpPr/>
+          <p:nvPr/>
+        </p:nvSpPr>
+        <p:spPr>
+          <a:xfrm>
+            <a:off x="0" y="0"/>
+            <a:ext cx="12188952" cy="6858000"/>
+          </a:xfrm>
+          <a:prstGeom prst="rect">
+            <a:avLst/>
+          </a:prstGeom>
+          <a:solidFill>
+            <a:srgbClr val="EDEDF3"/>
+          </a:solidFill>
+          <a:ln>
+            <a:noFill/>
+          </a:ln>
+        </p:spPr>
+        <p:style>
+          <a:lnRef idx="1">
+            <a:schemeClr val="accent1"/>
+          </a:lnRef>
+          <a:fillRef idx="3">
+            <a:schemeClr val="accent1"/>
+          </a:fillRef>
+          <a:effectRef idx="2">
+            <a:schemeClr val="accent1"/>
+          </a:effectRef>
+          <a:fontRef idx="minor">
+            <a:schemeClr val="lt1"/>
+          </a:fontRef>
+        </p:style>
+        <p:txBody>
+          <a:bodyPr rtlCol="0" anchor="ctr"/>
+          <a:lstStyle/>
+          <a:p>
+            <a:pPr algn="ctr"/>
+          </a:p>
+        </p:txBody>
+      </p:sp>
+      <p:sp>
+        <p:nvSpPr>
+          <p:cNvPr id="3" name="Rectangle 2"/>
+          <p:cNvSpPr/>
+          <p:nvPr/>
+        </p:nvSpPr>
+        <p:spPr>
+          <a:xfrm>
+            <a:off x="0" y="0"/>
+            <a:ext cx="12188952" cy="50292"/>
+          </a:xfrm>
+          <a:prstGeom prst="rect">
+            <a:avLst/>
+          </a:prstGeom>
+          <a:solidFill>
+            <a:srgbClr val="1F2C56"/>
+          </a:solidFill>
+          <a:ln>
+            <a:noFill/>
+          </a:ln>
+        </p:spPr>
+        <p:style>
+          <a:lnRef idx="1">
+            <a:schemeClr val="accent1"/>
+          </a:lnRef>
+          <a:fillRef idx="3">
+            <a:schemeClr val="accent1"/>
+          </a:fillRef>
+          <a:effectRef idx="2">
+            <a:schemeClr val="accent1"/>
+          </a:effectRef>
+          <a:fontRef idx="minor">
+            <a:schemeClr val="lt1"/>
+          </a:fontRef>
+        </p:style>
+        <p:txBody>
+          <a:bodyPr rtlCol="0" anchor="ctr"/>
+          <a:lstStyle/>
+          <a:p>
+            <a:pPr algn="ctr"/>
+          </a:p>
+        </p:txBody>
+      </p:sp>
+      <p:sp>
+        <p:nvSpPr>
+          <p:cNvPr id="4" name="TextBox 3"/>
+          <p:cNvSpPr txBox="1"/>
+          <p:nvPr/>
+        </p:nvSpPr>
+        <p:spPr>
+          <a:xfrm>
+            <a:off x="685800" y="109728"/>
+            <a:ext cx="10817352" cy="228600"/>
+          </a:xfrm>
+          <a:prstGeom prst="rect">
+            <a:avLst/>
+          </a:prstGeom>
+          <a:noFill/>
+        </p:spPr>
+        <p:txBody>
+          <a:bodyPr wrap="none">
+            <a:spAutoFit/>
+          </a:bodyPr>
+          <a:lstStyle/>
+          <a:p>
+            <a:pPr algn="l"/>
+            <a:r>
+              <a:rPr sz="750">
+                <a:solidFill>
+                  <a:srgbClr val="78808C"/>
+                </a:solidFill>
+                <a:latin typeface="Consolas"/>
+              </a:rPr>
+              <a:t>VA00  ·  INHALT</a:t>
+            </a:r>
+          </a:p>
+        </p:txBody>
+      </p:sp>
+      <p:sp>
+        <p:nvSpPr>
+          <p:cNvPr id="5" name="Rectangle 4"/>
+          <p:cNvSpPr/>
+          <p:nvPr/>
+        </p:nvSpPr>
+        <p:spPr>
+          <a:xfrm>
+            <a:off x="0" y="1234440"/>
+            <a:ext cx="12188952" cy="12700"/>
+          </a:xfrm>
+          <a:prstGeom prst="rect">
+            <a:avLst/>
+          </a:prstGeom>
+          <a:solidFill>
+            <a:srgbClr val="D8DFE4"/>
+          </a:solidFill>
+          <a:ln>
+            <a:noFill/>
+          </a:ln>
+        </p:spPr>
+        <p:style>
+          <a:lnRef idx="1">
+            <a:schemeClr val="accent1"/>
+          </a:lnRef>
+          <a:fillRef idx="3">
+            <a:schemeClr val="accent1"/>
+          </a:fillRef>
+          <a:effectRef idx="2">
+            <a:schemeClr val="accent1"/>
+          </a:effectRef>
+          <a:fontRef idx="minor">
+            <a:schemeClr val="lt1"/>
+          </a:fontRef>
+        </p:style>
+        <p:txBody>
+          <a:bodyPr rtlCol="0" anchor="ctr"/>
+          <a:lstStyle/>
+          <a:p>
+            <a:pPr algn="ctr"/>
+          </a:p>
+        </p:txBody>
+      </p:sp>
+      <p:sp>
+        <p:nvSpPr>
+          <p:cNvPr id="6" name="Rectangle 5"/>
+          <p:cNvSpPr/>
+          <p:nvPr/>
+        </p:nvSpPr>
+        <p:spPr>
+          <a:xfrm>
+            <a:off x="685800" y="502920"/>
+            <a:ext cx="36576" cy="658368"/>
+          </a:xfrm>
+          <a:prstGeom prst="rect">
+            <a:avLst/>
+          </a:prstGeom>
+          <a:solidFill>
+            <a:srgbClr val="D9C089"/>
+          </a:solidFill>
+          <a:ln>
+            <a:noFill/>
+          </a:ln>
+        </p:spPr>
+        <p:style>
+          <a:lnRef idx="1">
+            <a:schemeClr val="accent1"/>
+          </a:lnRef>
+          <a:fillRef idx="3">
+            <a:schemeClr val="accent1"/>
+          </a:fillRef>
+          <a:effectRef idx="2">
+            <a:schemeClr val="accent1"/>
+          </a:effectRef>
+          <a:fontRef idx="minor">
+            <a:schemeClr val="lt1"/>
+          </a:fontRef>
+        </p:style>
+        <p:txBody>
+          <a:bodyPr rtlCol="0" anchor="ctr"/>
+          <a:lstStyle/>
+          <a:p>
+            <a:pPr algn="ctr"/>
+          </a:p>
+        </p:txBody>
+      </p:sp>
+      <p:sp>
+        <p:nvSpPr>
+          <p:cNvPr id="7" name="TextBox 6"/>
+          <p:cNvSpPr txBox="1"/>
+          <p:nvPr/>
+        </p:nvSpPr>
+        <p:spPr>
+          <a:xfrm>
+            <a:off x="813816" y="502920"/>
+            <a:ext cx="10634472" cy="685800"/>
+          </a:xfrm>
+          <a:prstGeom prst="rect">
+            <a:avLst/>
+          </a:prstGeom>
+          <a:noFill/>
+        </p:spPr>
+        <p:txBody>
+          <a:bodyPr wrap="square">
+            <a:spAutoFit/>
+          </a:bodyPr>
+          <a:lstStyle/>
+          <a:p>
+            <a:pPr algn="l"/>
+            <a:r>
+              <a:rPr sz="2400" b="1" i="0">
+                <a:solidFill>
+                  <a:srgbClr val="1F2C56"/>
+                </a:solidFill>
+                <a:latin typeface="Arial"/>
+              </a:rPr>
+              <a:t>Handlungsempfehlung: im Zweifel die richtige Stelle finden</a:t>
+            </a:r>
+          </a:p>
+        </p:txBody>
+      </p:sp>
+      <p:sp>
+        <p:nvSpPr>
+          <p:cNvPr id="8" name="TextBox 7"/>
+          <p:cNvSpPr txBox="1"/>
+          <p:nvPr/>
+        </p:nvSpPr>
+        <p:spPr>
+          <a:xfrm>
+            <a:off x="685800" y="1417320"/>
+            <a:ext cx="10817352" cy="4892040"/>
+          </a:xfrm>
+          <a:prstGeom prst="rect">
+            <a:avLst/>
+          </a:prstGeom>
+          <a:noFill/>
+        </p:spPr>
+        <p:txBody>
+          <a:bodyPr wrap="square" anchor="ctr">
+            <a:spAutoFit/>
+          </a:bodyPr>
+          <a:lstStyle/>
+          <a:p>
+            <a:pPr marL="177800" indent="-177800">
+              <a:spcBef>
+                <a:spcPts val="600"/>
+              </a:spcBef>
+              <a:spcAft>
+                <a:spcPts val="200"/>
+              </a:spcAft>
+            </a:pPr>
+            <a:r>
+              <a:rPr sz="1200" i="1">
+                <a:solidFill>
+                  <a:srgbClr val="3D5466"/>
+                </a:solidFill>
+                <a:latin typeface="Arial"/>
+              </a:rPr>
+              <a:t>→  Wenn Sie unsicher sind, ob eine Aufgabe dem Markt oder der Marktfolge zufällt — dann die Regel nutzen: das Votum und die Kreditentscheidung liegen immer bei der Marktfolge.</a:t>
+            </a:r>
+          </a:p>
+          <a:p>
+            <a:pPr marL="177800" indent="-177800">
+              <a:spcBef>
+                <a:spcPts val="600"/>
+              </a:spcBef>
+              <a:spcAft>
+                <a:spcPts val="200"/>
+              </a:spcAft>
+            </a:pPr>
+            <a:r>
+              <a:rPr sz="1200" i="1">
+                <a:solidFill>
+                  <a:srgbClr val="3D5466"/>
+                </a:solidFill>
+                <a:latin typeface="Arial"/>
+              </a:rPr>
+              <a:t>→  Wenn Sie eine Information erhalten — dann prüfen, in welches der vier Felder sie gehört, und sie dort (im System) verorten.</a:t>
+            </a:r>
+          </a:p>
+          <a:p>
+            <a:pPr marL="177800" indent="-177800">
+              <a:spcBef>
+                <a:spcPts val="600"/>
+              </a:spcBef>
+              <a:spcAft>
+                <a:spcPts val="200"/>
+              </a:spcAft>
+            </a:pPr>
+            <a:r>
+              <a:rPr sz="1200" i="1">
+                <a:solidFill>
+                  <a:srgbClr val="3D5466"/>
+                </a:solidFill>
+                <a:latin typeface="Arial"/>
+              </a:rPr>
+              <a:t>→  Wenn Sie etwas noch nicht wissen — dann es in der ersten Woche gezielt mit Berater oder Teamleitung klären und in die Orientierungskarte eintragen.</a:t>
+            </a:r>
+          </a:p>
+        </p:txBody>
+      </p:sp>
+      <p:sp>
+        <p:nvSpPr>
+          <p:cNvPr id="9" name="Rectangle 8"/>
+          <p:cNvSpPr/>
+          <p:nvPr/>
+        </p:nvSpPr>
+        <p:spPr>
+          <a:xfrm>
+            <a:off x="0" y="6510528"/>
+            <a:ext cx="12188952" cy="347472"/>
+          </a:xfrm>
+          <a:prstGeom prst="rect">
+            <a:avLst/>
+          </a:prstGeom>
+          <a:solidFill>
+            <a:srgbClr val="0A1937"/>
+          </a:solidFill>
+          <a:ln>
+            <a:noFill/>
+          </a:ln>
+        </p:spPr>
+        <p:style>
+          <a:lnRef idx="1">
+            <a:schemeClr val="accent1"/>
+          </a:lnRef>
+          <a:fillRef idx="3">
+            <a:schemeClr val="accent1"/>
+          </a:fillRef>
+          <a:effectRef idx="2">
+            <a:schemeClr val="accent1"/>
+          </a:effectRef>
+          <a:fontRef idx="minor">
+            <a:schemeClr val="lt1"/>
+          </a:fontRef>
+        </p:style>
+        <p:txBody>
+          <a:bodyPr rtlCol="0" anchor="ctr"/>
+          <a:lstStyle/>
+          <a:p>
+            <a:pPr algn="ctr"/>
+          </a:p>
+        </p:txBody>
+      </p:sp>
+      <p:sp>
+        <p:nvSpPr>
+          <p:cNvPr id="10" name="TextBox 9"/>
+          <p:cNvSpPr txBox="1"/>
+          <p:nvPr/>
+        </p:nvSpPr>
+        <p:spPr>
+          <a:xfrm>
+            <a:off x="685800" y="6583680"/>
+            <a:ext cx="6490411" cy="256032"/>
+          </a:xfrm>
+          <a:prstGeom prst="rect">
+            <a:avLst/>
+          </a:prstGeom>
+          <a:noFill/>
+        </p:spPr>
+        <p:txBody>
+          <a:bodyPr wrap="none">
+            <a:spAutoFit/>
+          </a:bodyPr>
+          <a:lstStyle/>
+          <a:p>
+            <a:pPr algn="l"/>
+            <a:r>
+              <a:rPr sz="700">
+                <a:solidFill>
+                  <a:srgbClr val="A0B4D2"/>
+                </a:solidFill>
+                <a:latin typeface="Consolas"/>
+              </a:rPr>
+              <a:t>FKB Campus  ·  VA00</a:t>
+            </a:r>
+          </a:p>
+        </p:txBody>
+      </p:sp>
+    </p:spTree>
+  </p:cSld>
+  <p:clrMapOvr>
+    <a:masterClrMapping/>
+  </p:clrMapOvr>
+</p:sld>
+</file>
+
+<file path=ppt/slides/slide14.xml><?xml version="1.0" encoding="utf-8"?>
+<p:sld xmlns:a="http://schemas.openxmlformats.org/drawingml/2006/main" xmlns:p="http://schemas.openxmlformats.org/presentationml/2006/main" xmlns:r="http://schemas.openxmlformats.org/officeDocument/2006/relationships">
+  <p:cSld>
+    <p:spTree>
+      <p:nvGrpSpPr>
+        <p:cNvPr id="1" name=""/>
+        <p:cNvGrpSpPr/>
+        <p:nvPr/>
+      </p:nvGrpSpPr>
+      <p:grpSpPr/>
+      <p:sp>
+        <p:nvSpPr>
+          <p:cNvPr id="2" name="Rectangle 1"/>
+          <p:cNvSpPr/>
+          <p:nvPr/>
+        </p:nvSpPr>
+        <p:spPr>
+          <a:xfrm>
+            <a:off x="0" y="0"/>
+            <a:ext cx="12188952" cy="6858000"/>
+          </a:xfrm>
+          <a:prstGeom prst="rect">
+            <a:avLst/>
+          </a:prstGeom>
+          <a:solidFill>
+            <a:srgbClr val="EDEDF3"/>
+          </a:solidFill>
+          <a:ln>
+            <a:noFill/>
+          </a:ln>
+        </p:spPr>
+        <p:style>
+          <a:lnRef idx="1">
+            <a:schemeClr val="accent1"/>
+          </a:lnRef>
+          <a:fillRef idx="3">
+            <a:schemeClr val="accent1"/>
+          </a:fillRef>
+          <a:effectRef idx="2">
+            <a:schemeClr val="accent1"/>
+          </a:effectRef>
+          <a:fontRef idx="minor">
+            <a:schemeClr val="lt1"/>
+          </a:fontRef>
+        </p:style>
+        <p:txBody>
+          <a:bodyPr rtlCol="0" anchor="ctr"/>
+          <a:lstStyle/>
+          <a:p>
+            <a:pPr algn="ctr"/>
+          </a:p>
+        </p:txBody>
+      </p:sp>
+      <p:sp>
+        <p:nvSpPr>
+          <p:cNvPr id="3" name="Rectangle 2"/>
+          <p:cNvSpPr/>
+          <p:nvPr/>
+        </p:nvSpPr>
+        <p:spPr>
+          <a:xfrm>
+            <a:off x="0" y="0"/>
+            <a:ext cx="12188952" cy="50292"/>
+          </a:xfrm>
+          <a:prstGeom prst="rect">
+            <a:avLst/>
+          </a:prstGeom>
+          <a:solidFill>
+            <a:srgbClr val="1F2C56"/>
+          </a:solidFill>
+          <a:ln>
+            <a:noFill/>
+          </a:ln>
+        </p:spPr>
+        <p:style>
+          <a:lnRef idx="1">
+            <a:schemeClr val="accent1"/>
+          </a:lnRef>
+          <a:fillRef idx="3">
+            <a:schemeClr val="accent1"/>
+          </a:fillRef>
+          <a:effectRef idx="2">
+            <a:schemeClr val="accent1"/>
+          </a:effectRef>
+          <a:fontRef idx="minor">
+            <a:schemeClr val="lt1"/>
+          </a:fontRef>
+        </p:style>
+        <p:txBody>
+          <a:bodyPr rtlCol="0" anchor="ctr"/>
+          <a:lstStyle/>
+          <a:p>
+            <a:pPr algn="ctr"/>
+          </a:p>
+        </p:txBody>
+      </p:sp>
+      <p:sp>
+        <p:nvSpPr>
+          <p:cNvPr id="4" name="TextBox 3"/>
+          <p:cNvSpPr txBox="1"/>
+          <p:nvPr/>
+        </p:nvSpPr>
+        <p:spPr>
+          <a:xfrm>
+            <a:off x="685800" y="109728"/>
+            <a:ext cx="10817352" cy="228600"/>
+          </a:xfrm>
+          <a:prstGeom prst="rect">
+            <a:avLst/>
+          </a:prstGeom>
+          <a:noFill/>
+        </p:spPr>
+        <p:txBody>
+          <a:bodyPr wrap="none">
+            <a:spAutoFit/>
+          </a:bodyPr>
+          <a:lstStyle/>
+          <a:p>
+            <a:pPr algn="l"/>
+            <a:r>
+              <a:rPr sz="750">
+                <a:solidFill>
+                  <a:srgbClr val="78808C"/>
+                </a:solidFill>
+                <a:latin typeface="Consolas"/>
+              </a:rPr>
+              <a:t>VA00  ·  ARBEITSBLATT</a:t>
+            </a:r>
+          </a:p>
+        </p:txBody>
+      </p:sp>
+      <p:sp>
+        <p:nvSpPr>
+          <p:cNvPr id="5" name="Rectangle 4"/>
+          <p:cNvSpPr/>
+          <p:nvPr/>
+        </p:nvSpPr>
+        <p:spPr>
+          <a:xfrm>
+            <a:off x="0" y="1234440"/>
+            <a:ext cx="12188952" cy="12700"/>
+          </a:xfrm>
+          <a:prstGeom prst="rect">
+            <a:avLst/>
+          </a:prstGeom>
+          <a:solidFill>
+            <a:srgbClr val="D8DFE4"/>
+          </a:solidFill>
+          <a:ln>
+            <a:noFill/>
+          </a:ln>
+        </p:spPr>
+        <p:style>
+          <a:lnRef idx="1">
+            <a:schemeClr val="accent1"/>
+          </a:lnRef>
+          <a:fillRef idx="3">
+            <a:schemeClr val="accent1"/>
+          </a:fillRef>
+          <a:effectRef idx="2">
+            <a:schemeClr val="accent1"/>
+          </a:effectRef>
+          <a:fontRef idx="minor">
+            <a:schemeClr val="lt1"/>
+          </a:fontRef>
+        </p:style>
+        <p:txBody>
+          <a:bodyPr rtlCol="0" anchor="ctr"/>
+          <a:lstStyle/>
+          <a:p>
+            <a:pPr algn="ctr"/>
+          </a:p>
+        </p:txBody>
+      </p:sp>
+      <p:sp>
+        <p:nvSpPr>
+          <p:cNvPr id="6" name="Rectangle 5"/>
+          <p:cNvSpPr/>
+          <p:nvPr/>
+        </p:nvSpPr>
+        <p:spPr>
+          <a:xfrm>
+            <a:off x="685800" y="502920"/>
+            <a:ext cx="36576" cy="658368"/>
+          </a:xfrm>
+          <a:prstGeom prst="rect">
+            <a:avLst/>
+          </a:prstGeom>
+          <a:solidFill>
+            <a:srgbClr val="D9C089"/>
+          </a:solidFill>
+          <a:ln>
+            <a:noFill/>
+          </a:ln>
+        </p:spPr>
+        <p:style>
+          <a:lnRef idx="1">
+            <a:schemeClr val="accent1"/>
+          </a:lnRef>
+          <a:fillRef idx="3">
+            <a:schemeClr val="accent1"/>
+          </a:fillRef>
+          <a:effectRef idx="2">
+            <a:schemeClr val="accent1"/>
+          </a:effectRef>
+          <a:fontRef idx="minor">
+            <a:schemeClr val="lt1"/>
+          </a:fontRef>
+        </p:style>
+        <p:txBody>
+          <a:bodyPr rtlCol="0" anchor="ctr"/>
+          <a:lstStyle/>
+          <a:p>
+            <a:pPr algn="ctr"/>
+          </a:p>
+        </p:txBody>
+      </p:sp>
+      <p:sp>
+        <p:nvSpPr>
+          <p:cNvPr id="7" name="TextBox 6"/>
+          <p:cNvSpPr txBox="1"/>
+          <p:nvPr/>
+        </p:nvSpPr>
+        <p:spPr>
+          <a:xfrm>
+            <a:off x="813816" y="502920"/>
+            <a:ext cx="10634472" cy="685800"/>
+          </a:xfrm>
+          <a:prstGeom prst="rect">
+            <a:avLst/>
+          </a:prstGeom>
+          <a:noFill/>
+        </p:spPr>
+        <p:txBody>
+          <a:bodyPr wrap="square">
+            <a:spAutoFit/>
+          </a:bodyPr>
+          <a:lstStyle/>
+          <a:p>
+            <a:pPr algn="l"/>
+            <a:r>
+              <a:rPr sz="2400" b="1" i="0">
+                <a:solidFill>
+                  <a:srgbClr val="1F2C56"/>
+                </a:solidFill>
+                <a:latin typeface="Arial"/>
+              </a:rPr>
+              <a:t>Praxisaufgabe: die eigene Landkarte befüllen</a:t>
+            </a:r>
+          </a:p>
+        </p:txBody>
+      </p:sp>
+      <p:sp>
+        <p:nvSpPr>
+          <p:cNvPr id="8" name="TextBox 7"/>
+          <p:cNvSpPr txBox="1"/>
+          <p:nvPr/>
+        </p:nvSpPr>
+        <p:spPr>
+          <a:xfrm>
+            <a:off x="685800" y="1554480"/>
+            <a:ext cx="10817352" cy="3840480"/>
+          </a:xfrm>
+          <a:prstGeom prst="rect">
+            <a:avLst/>
+          </a:prstGeom>
+          <a:noFill/>
+        </p:spPr>
+        <p:txBody>
+          <a:bodyPr wrap="square">
+            <a:spAutoFit/>
+          </a:bodyPr>
+          <a:lstStyle/>
+          <a:p>
+            <a:pPr marL="190500" indent="-190500">
+              <a:spcBef>
+                <a:spcPts val="400"/>
+              </a:spcBef>
+              <a:spcAft>
+                <a:spcPts val="200"/>
+              </a:spcAft>
+            </a:pPr>
+            <a:r>
+              <a:rPr sz="1400">
+                <a:solidFill>
+                  <a:srgbClr val="3D5466"/>
+                </a:solidFill>
+                <a:latin typeface="Arial"/>
+              </a:rPr>
+              <a:t>▸  Füllen Sie die Haus-Landkarte für die Felder Produkte/Verbund und Prozesse/Rollen aus (AB-1, AB-2).</a:t>
+            </a:r>
+          </a:p>
+          <a:p>
+            <a:pPr marL="190500" indent="-190500">
+              <a:spcBef>
+                <a:spcPts val="400"/>
+              </a:spcBef>
+              <a:spcAft>
+                <a:spcPts val="200"/>
+              </a:spcAft>
+            </a:pPr>
+            <a:r>
+              <a:rPr sz="1400">
+                <a:solidFill>
+                  <a:srgbClr val="3D5466"/>
+                </a:solidFill>
+                <a:latin typeface="Arial"/>
+              </a:rPr>
+              <a:t>▸  Ordnen Sie die Kreditprozess-Rollen zu: Wer macht was? (AB-3).</a:t>
+            </a:r>
+          </a:p>
+          <a:p>
+            <a:pPr marL="190500" indent="-190500">
+              <a:spcBef>
+                <a:spcPts val="400"/>
+              </a:spcBef>
+              <a:spcAft>
+                <a:spcPts val="200"/>
+              </a:spcAft>
+            </a:pPr>
+            <a:r>
+              <a:rPr sz="1400">
+                <a:solidFill>
+                  <a:srgbClr val="3D5466"/>
+                </a:solidFill>
+                <a:latin typeface="Arial"/>
+              </a:rPr>
+              <a:t>▸  Ordnen Sie die Systeme ihrem Einsatzzweck zu (AB-4).</a:t>
+            </a:r>
+          </a:p>
+          <a:p>
+            <a:pPr marL="190500" indent="-190500">
+              <a:spcBef>
+                <a:spcPts val="400"/>
+              </a:spcBef>
+              <a:spcAft>
+                <a:spcPts val="200"/>
+              </a:spcAft>
+            </a:pPr>
+            <a:r>
+              <a:rPr sz="1400">
+                <a:solidFill>
+                  <a:srgbClr val="3D5466"/>
+                </a:solidFill>
+                <a:latin typeface="Arial"/>
+              </a:rPr>
+              <a:t>▸  Beginnen Sie Ihre Orientierungskarte mit realen Namen und Kontakten (AB-5) – Rest in der ersten Woche.</a:t>
+            </a:r>
+          </a:p>
+        </p:txBody>
+      </p:sp>
+      <p:sp>
+        <p:nvSpPr>
+          <p:cNvPr id="9" name="Rectangle 8"/>
+          <p:cNvSpPr/>
+          <p:nvPr/>
+        </p:nvSpPr>
+        <p:spPr>
+          <a:xfrm>
+            <a:off x="685800" y="5486400"/>
+            <a:ext cx="10817352" cy="640080"/>
+          </a:xfrm>
+          <a:prstGeom prst="rect">
+            <a:avLst/>
+          </a:prstGeom>
+          <a:solidFill>
+            <a:srgbClr val="1F2C56"/>
+          </a:solidFill>
+          <a:ln>
+            <a:noFill/>
+          </a:ln>
+        </p:spPr>
+        <p:style>
+          <a:lnRef idx="1">
+            <a:schemeClr val="accent1"/>
+          </a:lnRef>
+          <a:fillRef idx="3">
+            <a:schemeClr val="accent1"/>
+          </a:fillRef>
+          <a:effectRef idx="2">
+            <a:schemeClr val="accent1"/>
+          </a:effectRef>
+          <a:fontRef idx="minor">
+            <a:schemeClr val="lt1"/>
+          </a:fontRef>
+        </p:style>
+        <p:txBody>
+          <a:bodyPr rtlCol="0" anchor="ctr"/>
+          <a:lstStyle/>
+          <a:p>
+            <a:pPr algn="ctr"/>
+          </a:p>
+        </p:txBody>
+      </p:sp>
+      <p:sp>
+        <p:nvSpPr>
+          <p:cNvPr id="10" name="TextBox 9"/>
+          <p:cNvSpPr txBox="1"/>
+          <p:nvPr/>
+        </p:nvSpPr>
+        <p:spPr>
+          <a:xfrm>
+            <a:off x="868680" y="5596128"/>
+            <a:ext cx="10451592" cy="457200"/>
+          </a:xfrm>
+          <a:prstGeom prst="rect">
+            <a:avLst/>
+          </a:prstGeom>
+          <a:noFill/>
+        </p:spPr>
+        <p:txBody>
+          <a:bodyPr wrap="square">
+            <a:spAutoFit/>
+          </a:bodyPr>
+          <a:lstStyle/>
+          <a:p>
+            <a:pPr algn="l"/>
+            <a:r>
+              <a:rPr sz="1300" b="1" i="0">
+                <a:solidFill>
+                  <a:srgbClr val="FFFFFF"/>
+                </a:solidFill>
+                <a:latin typeface="Arial"/>
+              </a:rPr>
+              <a:t>→  Bearbeitung im Teilnehmer-Workbook (Arbeitsblatt mit Ausfüllfeldern)</a:t>
+            </a:r>
+          </a:p>
+        </p:txBody>
+      </p:sp>
+      <p:sp>
+        <p:nvSpPr>
+          <p:cNvPr id="11" name="Rectangle 10"/>
+          <p:cNvSpPr/>
+          <p:nvPr/>
+        </p:nvSpPr>
+        <p:spPr>
+          <a:xfrm>
+            <a:off x="0" y="6510528"/>
+            <a:ext cx="12188952" cy="347472"/>
+          </a:xfrm>
+          <a:prstGeom prst="rect">
+            <a:avLst/>
+          </a:prstGeom>
+          <a:solidFill>
+            <a:srgbClr val="0A1937"/>
+          </a:solidFill>
+          <a:ln>
+            <a:noFill/>
+          </a:ln>
+        </p:spPr>
+        <p:style>
+          <a:lnRef idx="1">
+            <a:schemeClr val="accent1"/>
+          </a:lnRef>
+          <a:fillRef idx="3">
+            <a:schemeClr val="accent1"/>
+          </a:fillRef>
+          <a:effectRef idx="2">
+            <a:schemeClr val="accent1"/>
+          </a:effectRef>
+          <a:fontRef idx="minor">
+            <a:schemeClr val="lt1"/>
+          </a:fontRef>
+        </p:style>
+        <p:txBody>
+          <a:bodyPr rtlCol="0" anchor="ctr"/>
+          <a:lstStyle/>
+          <a:p>
+            <a:pPr algn="ctr"/>
+          </a:p>
+        </p:txBody>
+      </p:sp>
+      <p:sp>
+        <p:nvSpPr>
+          <p:cNvPr id="12" name="TextBox 11"/>
+          <p:cNvSpPr txBox="1"/>
+          <p:nvPr/>
+        </p:nvSpPr>
+        <p:spPr>
+          <a:xfrm>
+            <a:off x="685800" y="6583680"/>
+            <a:ext cx="6490411" cy="256032"/>
+          </a:xfrm>
+          <a:prstGeom prst="rect">
+            <a:avLst/>
+          </a:prstGeom>
+          <a:noFill/>
+        </p:spPr>
+        <p:txBody>
+          <a:bodyPr wrap="none">
+            <a:spAutoFit/>
+          </a:bodyPr>
+          <a:lstStyle/>
+          <a:p>
+            <a:pPr algn="l"/>
+            <a:r>
+              <a:rPr sz="700">
+                <a:solidFill>
+                  <a:srgbClr val="A0B4D2"/>
+                </a:solidFill>
+                <a:latin typeface="Consolas"/>
+              </a:rPr>
+              <a:t>FKB Campus  ·  VA00</a:t>
+            </a:r>
+          </a:p>
+        </p:txBody>
+      </p:sp>
+    </p:spTree>
+  </p:cSld>
+  <p:clrMapOvr>
+    <a:masterClrMapping/>
+  </p:clrMapOvr>
+</p:sld>
+</file>
+
+<file path=ppt/slides/slide15.xml><?xml version="1.0" encoding="utf-8"?>
+<p:sld xmlns:a="http://schemas.openxmlformats.org/drawingml/2006/main" xmlns:p="http://schemas.openxmlformats.org/presentationml/2006/main" xmlns:r="http://schemas.openxmlformats.org/officeDocument/2006/relationships">
+  <p:cSld>
+    <p:spTree>
+      <p:nvGrpSpPr>
+        <p:cNvPr id="1" name=""/>
+        <p:cNvGrpSpPr/>
+        <p:nvPr/>
+      </p:nvGrpSpPr>
+      <p:grpSpPr/>
+      <p:sp>
+        <p:nvSpPr>
+          <p:cNvPr id="2" name="Rectangle 1"/>
+          <p:cNvSpPr/>
+          <p:nvPr/>
+        </p:nvSpPr>
+        <p:spPr>
+          <a:xfrm>
+            <a:off x="0" y="0"/>
+            <a:ext cx="12188952" cy="6858000"/>
+          </a:xfrm>
+          <a:prstGeom prst="rect">
+            <a:avLst/>
+          </a:prstGeom>
+          <a:solidFill>
+            <a:srgbClr val="EDEDF3"/>
+          </a:solidFill>
+          <a:ln>
+            <a:noFill/>
+          </a:ln>
+        </p:spPr>
+        <p:style>
+          <a:lnRef idx="1">
+            <a:schemeClr val="accent1"/>
+          </a:lnRef>
+          <a:fillRef idx="3">
+            <a:schemeClr val="accent1"/>
+          </a:fillRef>
+          <a:effectRef idx="2">
+            <a:schemeClr val="accent1"/>
+          </a:effectRef>
+          <a:fontRef idx="minor">
+            <a:schemeClr val="lt1"/>
+          </a:fontRef>
+        </p:style>
+        <p:txBody>
+          <a:bodyPr rtlCol="0" anchor="ctr"/>
+          <a:lstStyle/>
+          <a:p>
+            <a:pPr algn="ctr"/>
+          </a:p>
+        </p:txBody>
+      </p:sp>
+      <p:sp>
+        <p:nvSpPr>
+          <p:cNvPr id="3" name="Rectangle 2"/>
+          <p:cNvSpPr/>
+          <p:nvPr/>
+        </p:nvSpPr>
+        <p:spPr>
+          <a:xfrm>
+            <a:off x="0" y="0"/>
+            <a:ext cx="12188952" cy="50292"/>
+          </a:xfrm>
+          <a:prstGeom prst="rect">
+            <a:avLst/>
+          </a:prstGeom>
+          <a:solidFill>
+            <a:srgbClr val="1F2C56"/>
+          </a:solidFill>
+          <a:ln>
+            <a:noFill/>
+          </a:ln>
+        </p:spPr>
+        <p:style>
+          <a:lnRef idx="1">
+            <a:schemeClr val="accent1"/>
+          </a:lnRef>
+          <a:fillRef idx="3">
+            <a:schemeClr val="accent1"/>
+          </a:fillRef>
+          <a:effectRef idx="2">
+            <a:schemeClr val="accent1"/>
+          </a:effectRef>
+          <a:fontRef idx="minor">
+            <a:schemeClr val="lt1"/>
+          </a:fontRef>
+        </p:style>
+        <p:txBody>
+          <a:bodyPr rtlCol="0" anchor="ctr"/>
+          <a:lstStyle/>
+          <a:p>
+            <a:pPr algn="ctr"/>
+          </a:p>
+        </p:txBody>
+      </p:sp>
+      <p:sp>
+        <p:nvSpPr>
+          <p:cNvPr id="4" name="TextBox 3"/>
+          <p:cNvSpPr txBox="1"/>
+          <p:nvPr/>
+        </p:nvSpPr>
+        <p:spPr>
+          <a:xfrm>
+            <a:off x="685800" y="109728"/>
+            <a:ext cx="10817352" cy="228600"/>
+          </a:xfrm>
+          <a:prstGeom prst="rect">
+            <a:avLst/>
+          </a:prstGeom>
+          <a:noFill/>
+        </p:spPr>
+        <p:txBody>
+          <a:bodyPr wrap="none">
+            <a:spAutoFit/>
+          </a:bodyPr>
+          <a:lstStyle/>
+          <a:p>
+            <a:pPr algn="l"/>
+            <a:r>
+              <a:rPr sz="750">
+                <a:solidFill>
+                  <a:srgbClr val="78808C"/>
+                </a:solidFill>
+                <a:latin typeface="Consolas"/>
+              </a:rPr>
+              <a:t>VA00  ·  INHALT</a:t>
+            </a:r>
+          </a:p>
+        </p:txBody>
+      </p:sp>
+      <p:sp>
+        <p:nvSpPr>
+          <p:cNvPr id="5" name="Rectangle 4"/>
+          <p:cNvSpPr/>
+          <p:nvPr/>
+        </p:nvSpPr>
+        <p:spPr>
+          <a:xfrm>
+            <a:off x="0" y="1234440"/>
+            <a:ext cx="12188952" cy="12700"/>
+          </a:xfrm>
+          <a:prstGeom prst="rect">
+            <a:avLst/>
+          </a:prstGeom>
+          <a:solidFill>
+            <a:srgbClr val="D8DFE4"/>
+          </a:solidFill>
+          <a:ln>
+            <a:noFill/>
+          </a:ln>
+        </p:spPr>
+        <p:style>
+          <a:lnRef idx="1">
+            <a:schemeClr val="accent1"/>
+          </a:lnRef>
+          <a:fillRef idx="3">
+            <a:schemeClr val="accent1"/>
+          </a:fillRef>
+          <a:effectRef idx="2">
+            <a:schemeClr val="accent1"/>
+          </a:effectRef>
+          <a:fontRef idx="minor">
+            <a:schemeClr val="lt1"/>
+          </a:fontRef>
+        </p:style>
+        <p:txBody>
+          <a:bodyPr rtlCol="0" anchor="ctr"/>
+          <a:lstStyle/>
+          <a:p>
+            <a:pPr algn="ctr"/>
+          </a:p>
+        </p:txBody>
+      </p:sp>
+      <p:sp>
+        <p:nvSpPr>
+          <p:cNvPr id="6" name="Rectangle 5"/>
+          <p:cNvSpPr/>
+          <p:nvPr/>
+        </p:nvSpPr>
+        <p:spPr>
+          <a:xfrm>
+            <a:off x="685800" y="502920"/>
+            <a:ext cx="36576" cy="658368"/>
+          </a:xfrm>
+          <a:prstGeom prst="rect">
+            <a:avLst/>
+          </a:prstGeom>
+          <a:solidFill>
+            <a:srgbClr val="D9C089"/>
+          </a:solidFill>
+          <a:ln>
+            <a:noFill/>
+          </a:ln>
+        </p:spPr>
+        <p:style>
+          <a:lnRef idx="1">
+            <a:schemeClr val="accent1"/>
+          </a:lnRef>
+          <a:fillRef idx="3">
+            <a:schemeClr val="accent1"/>
+          </a:fillRef>
+          <a:effectRef idx="2">
+            <a:schemeClr val="accent1"/>
+          </a:effectRef>
+          <a:fontRef idx="minor">
+            <a:schemeClr val="lt1"/>
+          </a:fontRef>
+        </p:style>
+        <p:txBody>
+          <a:bodyPr rtlCol="0" anchor="ctr"/>
+          <a:lstStyle/>
+          <a:p>
+            <a:pPr algn="ctr"/>
+          </a:p>
+        </p:txBody>
+      </p:sp>
+      <p:sp>
+        <p:nvSpPr>
+          <p:cNvPr id="7" name="TextBox 6"/>
+          <p:cNvSpPr txBox="1"/>
+          <p:nvPr/>
+        </p:nvSpPr>
+        <p:spPr>
+          <a:xfrm>
+            <a:off x="813816" y="502920"/>
+            <a:ext cx="10634472" cy="685800"/>
+          </a:xfrm>
+          <a:prstGeom prst="rect">
+            <a:avLst/>
+          </a:prstGeom>
+          <a:noFill/>
+        </p:spPr>
+        <p:txBody>
+          <a:bodyPr wrap="square">
+            <a:spAutoFit/>
+          </a:bodyPr>
+          <a:lstStyle/>
+          <a:p>
+            <a:pPr algn="l"/>
+            <a:r>
+              <a:rPr sz="2400" b="1" i="0">
+                <a:solidFill>
+                  <a:srgbClr val="1F2C56"/>
+                </a:solidFill>
+                <a:latin typeface="Arial"/>
+              </a:rPr>
+              <a:t>Prinzip dieses Moduls</a:t>
+            </a:r>
+          </a:p>
+        </p:txBody>
+      </p:sp>
+      <p:sp>
+        <p:nvSpPr>
+          <p:cNvPr id="8" name="TextBox 7"/>
+          <p:cNvSpPr txBox="1"/>
+          <p:nvPr/>
+        </p:nvSpPr>
+        <p:spPr>
+          <a:xfrm>
+            <a:off x="685800" y="1417320"/>
+            <a:ext cx="10817352" cy="4892040"/>
+          </a:xfrm>
+          <a:prstGeom prst="rect">
+            <a:avLst/>
+          </a:prstGeom>
+          <a:noFill/>
+        </p:spPr>
+        <p:txBody>
+          <a:bodyPr wrap="square" anchor="ctr">
+            <a:spAutoFit/>
+          </a:bodyPr>
+          <a:lstStyle/>
+          <a:p>
+            <a:pPr marL="177800" indent="-177800">
+              <a:spcBef>
+                <a:spcPts val="600"/>
+              </a:spcBef>
+              <a:spcAft>
+                <a:spcPts val="200"/>
+              </a:spcAft>
+            </a:pPr>
+            <a:r>
+              <a:rPr sz="1200" i="1">
+                <a:solidFill>
+                  <a:srgbClr val="3D5466"/>
+                </a:solidFill>
+                <a:latin typeface="Arial"/>
+              </a:rPr>
+              <a:t>→  Wer das eigene Haus kennt, findet für jeden Fall die richtige Stelle.</a:t>
+            </a:r>
+          </a:p>
+          <a:p>
+            <a:pPr marL="190500" indent="-190500">
+              <a:spcBef>
+                <a:spcPts val="400"/>
+              </a:spcBef>
+              <a:spcAft>
+                <a:spcPts val="200"/>
+              </a:spcAft>
+            </a:pPr>
+            <a:r>
+              <a:rPr sz="1300">
+                <a:solidFill>
+                  <a:srgbClr val="3D5466"/>
+                </a:solidFill>
+                <a:latin typeface="Arial"/>
+              </a:rPr>
+              <a:t>▸  Produkte, Kreditprozess, Verbundpartner und Systeme im Überblick zu kennen macht aus Nachfragen eigenständiges Handeln.</a:t>
+            </a:r>
+          </a:p>
+        </p:txBody>
+      </p:sp>
+      <p:sp>
+        <p:nvSpPr>
+          <p:cNvPr id="9" name="Rectangle 8"/>
+          <p:cNvSpPr/>
+          <p:nvPr/>
+        </p:nvSpPr>
+        <p:spPr>
+          <a:xfrm>
+            <a:off x="0" y="6510528"/>
+            <a:ext cx="12188952" cy="347472"/>
+          </a:xfrm>
+          <a:prstGeom prst="rect">
+            <a:avLst/>
+          </a:prstGeom>
+          <a:solidFill>
+            <a:srgbClr val="0A1937"/>
+          </a:solidFill>
+          <a:ln>
+            <a:noFill/>
+          </a:ln>
+        </p:spPr>
+        <p:style>
+          <a:lnRef idx="1">
+            <a:schemeClr val="accent1"/>
+          </a:lnRef>
+          <a:fillRef idx="3">
+            <a:schemeClr val="accent1"/>
+          </a:fillRef>
+          <a:effectRef idx="2">
+            <a:schemeClr val="accent1"/>
+          </a:effectRef>
+          <a:fontRef idx="minor">
+            <a:schemeClr val="lt1"/>
+          </a:fontRef>
+        </p:style>
+        <p:txBody>
+          <a:bodyPr rtlCol="0" anchor="ctr"/>
+          <a:lstStyle/>
+          <a:p>
+            <a:pPr algn="ctr"/>
+          </a:p>
+        </p:txBody>
+      </p:sp>
+      <p:sp>
+        <p:nvSpPr>
+          <p:cNvPr id="10" name="TextBox 9"/>
+          <p:cNvSpPr txBox="1"/>
+          <p:nvPr/>
+        </p:nvSpPr>
+        <p:spPr>
+          <a:xfrm>
+            <a:off x="685800" y="6583680"/>
+            <a:ext cx="6490411" cy="256032"/>
+          </a:xfrm>
+          <a:prstGeom prst="rect">
+            <a:avLst/>
+          </a:prstGeom>
+          <a:noFill/>
+        </p:spPr>
+        <p:txBody>
+          <a:bodyPr wrap="none">
+            <a:spAutoFit/>
+          </a:bodyPr>
+          <a:lstStyle/>
+          <a:p>
+            <a:pPr algn="l"/>
+            <a:r>
+              <a:rPr sz="700">
+                <a:solidFill>
+                  <a:srgbClr val="A0B4D2"/>
+                </a:solidFill>
+                <a:latin typeface="Consolas"/>
+              </a:rPr>
+              <a:t>FKB Campus  ·  VA00</a:t>
+            </a:r>
+          </a:p>
+        </p:txBody>
+      </p:sp>
+    </p:spTree>
+  </p:cSld>
+  <p:clrMapOvr>
+    <a:masterClrMapping/>
+  </p:clrMapOvr>
+</p:sld>
+</file>
+
+<file path=ppt/slides/slide16.xml><?xml version="1.0" encoding="utf-8"?>
+<p:sld xmlns:a="http://schemas.openxmlformats.org/drawingml/2006/main" xmlns:p="http://schemas.openxmlformats.org/presentationml/2006/main" xmlns:r="http://schemas.openxmlformats.org/officeDocument/2006/relationships">
+  <p:cSld>
+    <p:spTree>
+      <p:nvGrpSpPr>
+        <p:cNvPr id="1" name=""/>
+        <p:cNvGrpSpPr/>
+        <p:nvPr/>
+      </p:nvGrpSpPr>
+      <p:grpSpPr/>
+      <p:sp>
+        <p:nvSpPr>
+          <p:cNvPr id="2" name="Rectangle 1"/>
+          <p:cNvSpPr/>
+          <p:nvPr/>
+        </p:nvSpPr>
+        <p:spPr>
+          <a:xfrm>
+            <a:off x="0" y="0"/>
+            <a:ext cx="12188952" cy="6858000"/>
+          </a:xfrm>
+          <a:prstGeom prst="rect">
+            <a:avLst/>
+          </a:prstGeom>
+          <a:solidFill>
+            <a:srgbClr val="EDEDF3"/>
+          </a:solidFill>
+          <a:ln>
+            <a:noFill/>
+          </a:ln>
+        </p:spPr>
+        <p:style>
+          <a:lnRef idx="1">
+            <a:schemeClr val="accent1"/>
+          </a:lnRef>
+          <a:fillRef idx="3">
+            <a:schemeClr val="accent1"/>
+          </a:fillRef>
+          <a:effectRef idx="2">
+            <a:schemeClr val="accent1"/>
+          </a:effectRef>
+          <a:fontRef idx="minor">
+            <a:schemeClr val="lt1"/>
+          </a:fontRef>
+        </p:style>
+        <p:txBody>
+          <a:bodyPr rtlCol="0" anchor="ctr"/>
+          <a:lstStyle/>
+          <a:p>
+            <a:pPr algn="ctr"/>
+          </a:p>
+        </p:txBody>
+      </p:sp>
+      <p:sp>
+        <p:nvSpPr>
+          <p:cNvPr id="3" name="Rectangle 2"/>
+          <p:cNvSpPr/>
+          <p:nvPr/>
+        </p:nvSpPr>
+        <p:spPr>
+          <a:xfrm>
+            <a:off x="0" y="0"/>
+            <a:ext cx="12188952" cy="50292"/>
+          </a:xfrm>
+          <a:prstGeom prst="rect">
+            <a:avLst/>
+          </a:prstGeom>
+          <a:solidFill>
+            <a:srgbClr val="1F2C56"/>
+          </a:solidFill>
+          <a:ln>
+            <a:noFill/>
+          </a:ln>
+        </p:spPr>
+        <p:style>
+          <a:lnRef idx="1">
+            <a:schemeClr val="accent1"/>
+          </a:lnRef>
+          <a:fillRef idx="3">
+            <a:schemeClr val="accent1"/>
+          </a:fillRef>
+          <a:effectRef idx="2">
+            <a:schemeClr val="accent1"/>
+          </a:effectRef>
+          <a:fontRef idx="minor">
+            <a:schemeClr val="lt1"/>
+          </a:fontRef>
+        </p:style>
+        <p:txBody>
+          <a:bodyPr rtlCol="0" anchor="ctr"/>
+          <a:lstStyle/>
+          <a:p>
+            <a:pPr algn="ctr"/>
+          </a:p>
+        </p:txBody>
+      </p:sp>
+      <p:sp>
+        <p:nvSpPr>
+          <p:cNvPr id="4" name="TextBox 3"/>
+          <p:cNvSpPr txBox="1"/>
+          <p:nvPr/>
+        </p:nvSpPr>
+        <p:spPr>
+          <a:xfrm>
+            <a:off x="685800" y="109728"/>
+            <a:ext cx="10817352" cy="228600"/>
+          </a:xfrm>
+          <a:prstGeom prst="rect">
+            <a:avLst/>
+          </a:prstGeom>
+          <a:noFill/>
+        </p:spPr>
+        <p:txBody>
+          <a:bodyPr wrap="none">
+            <a:spAutoFit/>
+          </a:bodyPr>
+          <a:lstStyle/>
+          <a:p>
+            <a:pPr algn="l"/>
+            <a:r>
+              <a:rPr sz="750">
+                <a:solidFill>
+                  <a:srgbClr val="78808C"/>
+                </a:solidFill>
+                <a:latin typeface="Consolas"/>
+              </a:rPr>
+              <a:t>VA00  ·  INHALT</a:t>
+            </a:r>
+          </a:p>
+        </p:txBody>
+      </p:sp>
+      <p:sp>
+        <p:nvSpPr>
+          <p:cNvPr id="5" name="Rectangle 4"/>
+          <p:cNvSpPr/>
+          <p:nvPr/>
+        </p:nvSpPr>
+        <p:spPr>
+          <a:xfrm>
+            <a:off x="0" y="1234440"/>
+            <a:ext cx="12188952" cy="12700"/>
+          </a:xfrm>
+          <a:prstGeom prst="rect">
+            <a:avLst/>
+          </a:prstGeom>
+          <a:solidFill>
+            <a:srgbClr val="D8DFE4"/>
+          </a:solidFill>
+          <a:ln>
+            <a:noFill/>
+          </a:ln>
+        </p:spPr>
+        <p:style>
+          <a:lnRef idx="1">
+            <a:schemeClr val="accent1"/>
+          </a:lnRef>
+          <a:fillRef idx="3">
+            <a:schemeClr val="accent1"/>
+          </a:fillRef>
+          <a:effectRef idx="2">
+            <a:schemeClr val="accent1"/>
+          </a:effectRef>
+          <a:fontRef idx="minor">
+            <a:schemeClr val="lt1"/>
+          </a:fontRef>
+        </p:style>
+        <p:txBody>
+          <a:bodyPr rtlCol="0" anchor="ctr"/>
+          <a:lstStyle/>
+          <a:p>
+            <a:pPr algn="ctr"/>
+          </a:p>
+        </p:txBody>
+      </p:sp>
+      <p:sp>
+        <p:nvSpPr>
+          <p:cNvPr id="6" name="Rectangle 5"/>
+          <p:cNvSpPr/>
+          <p:nvPr/>
+        </p:nvSpPr>
+        <p:spPr>
+          <a:xfrm>
+            <a:off x="685800" y="502920"/>
+            <a:ext cx="36576" cy="658368"/>
+          </a:xfrm>
+          <a:prstGeom prst="rect">
+            <a:avLst/>
+          </a:prstGeom>
+          <a:solidFill>
+            <a:srgbClr val="D9C089"/>
+          </a:solidFill>
+          <a:ln>
+            <a:noFill/>
+          </a:ln>
+        </p:spPr>
+        <p:style>
+          <a:lnRef idx="1">
+            <a:schemeClr val="accent1"/>
+          </a:lnRef>
+          <a:fillRef idx="3">
+            <a:schemeClr val="accent1"/>
+          </a:fillRef>
+          <a:effectRef idx="2">
+            <a:schemeClr val="accent1"/>
+          </a:effectRef>
+          <a:fontRef idx="minor">
+            <a:schemeClr val="lt1"/>
+          </a:fontRef>
+        </p:style>
+        <p:txBody>
+          <a:bodyPr rtlCol="0" anchor="ctr"/>
+          <a:lstStyle/>
+          <a:p>
+            <a:pPr algn="ctr"/>
+          </a:p>
+        </p:txBody>
+      </p:sp>
+      <p:sp>
+        <p:nvSpPr>
+          <p:cNvPr id="7" name="TextBox 6"/>
+          <p:cNvSpPr txBox="1"/>
+          <p:nvPr/>
+        </p:nvSpPr>
+        <p:spPr>
+          <a:xfrm>
+            <a:off x="813816" y="502920"/>
+            <a:ext cx="10634472" cy="685800"/>
+          </a:xfrm>
+          <a:prstGeom prst="rect">
+            <a:avLst/>
+          </a:prstGeom>
+          <a:noFill/>
+        </p:spPr>
+        <p:txBody>
+          <a:bodyPr wrap="square">
+            <a:spAutoFit/>
+          </a:bodyPr>
+          <a:lstStyle/>
+          <a:p>
+            <a:pPr algn="l"/>
+            <a:r>
+              <a:rPr sz="2400" b="1" i="0">
+                <a:solidFill>
+                  <a:srgbClr val="1F2C56"/>
+                </a:solidFill>
+                <a:latin typeface="Arial"/>
+              </a:rPr>
+              <a:t>Reflexionsfragen</a:t>
+            </a:r>
+          </a:p>
+        </p:txBody>
+      </p:sp>
+      <p:sp>
+        <p:nvSpPr>
+          <p:cNvPr id="8" name="TextBox 7"/>
+          <p:cNvSpPr txBox="1"/>
+          <p:nvPr/>
+        </p:nvSpPr>
+        <p:spPr>
+          <a:xfrm>
+            <a:off x="685800" y="1417320"/>
+            <a:ext cx="10817352" cy="4892040"/>
+          </a:xfrm>
+          <a:prstGeom prst="rect">
+            <a:avLst/>
+          </a:prstGeom>
+          <a:noFill/>
+        </p:spPr>
+        <p:txBody>
+          <a:bodyPr wrap="square" anchor="ctr">
+            <a:spAutoFit/>
+          </a:bodyPr>
+          <a:lstStyle/>
+          <a:p>
+            <a:pPr marL="190500" indent="-190500">
+              <a:spcBef>
+                <a:spcPts val="400"/>
+              </a:spcBef>
+              <a:spcAft>
+                <a:spcPts val="200"/>
+              </a:spcAft>
+            </a:pPr>
+            <a:r>
+              <a:rPr sz="1300">
+                <a:solidFill>
+                  <a:srgbClr val="3D5466"/>
+                </a:solidFill>
+                <a:latin typeface="Arial"/>
+              </a:rPr>
+              <a:t>▸  Welches der vier Felder ist Ihnen heute noch am unklarsten – und wen fragen Sie dazu zuerst?</a:t>
+            </a:r>
+          </a:p>
+          <a:p>
+            <a:pPr marL="190500" indent="-190500">
+              <a:spcBef>
+                <a:spcPts val="400"/>
+              </a:spcBef>
+              <a:spcAft>
+                <a:spcPts val="200"/>
+              </a:spcAft>
+            </a:pPr>
+            <a:r>
+              <a:rPr sz="1300">
+                <a:solidFill>
+                  <a:srgbClr val="3D5466"/>
+                </a:solidFill>
+                <a:latin typeface="Arial"/>
+              </a:rPr>
+              <a:t>▸  An welcher Stelle im Kreditprozess sehen Sie Ihren wichtigsten Beitrag?</a:t>
+            </a:r>
+          </a:p>
+          <a:p>
+            <a:pPr marL="190500" indent="-190500">
+              <a:spcBef>
+                <a:spcPts val="400"/>
+              </a:spcBef>
+              <a:spcAft>
+                <a:spcPts val="200"/>
+              </a:spcAft>
+            </a:pPr>
+            <a:r>
+              <a:rPr sz="1300">
+                <a:solidFill>
+                  <a:srgbClr val="3D5466"/>
+                </a:solidFill>
+                <a:latin typeface="Arial"/>
+              </a:rPr>
+              <a:t>▸  Was nehmen Sie aus heute mit – und was ist noch offen (grün / orange)?</a:t>
+            </a:r>
+          </a:p>
+        </p:txBody>
+      </p:sp>
+      <p:sp>
+        <p:nvSpPr>
+          <p:cNvPr id="9" name="Rectangle 8"/>
+          <p:cNvSpPr/>
+          <p:nvPr/>
+        </p:nvSpPr>
+        <p:spPr>
+          <a:xfrm>
+            <a:off x="0" y="6510528"/>
+            <a:ext cx="12188952" cy="347472"/>
+          </a:xfrm>
+          <a:prstGeom prst="rect">
+            <a:avLst/>
+          </a:prstGeom>
+          <a:solidFill>
+            <a:srgbClr val="0A1937"/>
+          </a:solidFill>
+          <a:ln>
+            <a:noFill/>
+          </a:ln>
+        </p:spPr>
+        <p:style>
+          <a:lnRef idx="1">
+            <a:schemeClr val="accent1"/>
+          </a:lnRef>
+          <a:fillRef idx="3">
+            <a:schemeClr val="accent1"/>
+          </a:fillRef>
+          <a:effectRef idx="2">
+            <a:schemeClr val="accent1"/>
+          </a:effectRef>
+          <a:fontRef idx="minor">
+            <a:schemeClr val="lt1"/>
+          </a:fontRef>
+        </p:style>
+        <p:txBody>
+          <a:bodyPr rtlCol="0" anchor="ctr"/>
+          <a:lstStyle/>
+          <a:p>
+            <a:pPr algn="ctr"/>
+          </a:p>
+        </p:txBody>
+      </p:sp>
+      <p:sp>
+        <p:nvSpPr>
+          <p:cNvPr id="10" name="TextBox 9"/>
+          <p:cNvSpPr txBox="1"/>
+          <p:nvPr/>
+        </p:nvSpPr>
+        <p:spPr>
+          <a:xfrm>
+            <a:off x="685800" y="6583680"/>
+            <a:ext cx="6490411" cy="256032"/>
+          </a:xfrm>
+          <a:prstGeom prst="rect">
+            <a:avLst/>
+          </a:prstGeom>
+          <a:noFill/>
+        </p:spPr>
+        <p:txBody>
+          <a:bodyPr wrap="none">
+            <a:spAutoFit/>
+          </a:bodyPr>
+          <a:lstStyle/>
+          <a:p>
+            <a:pPr algn="l"/>
+            <a:r>
+              <a:rPr sz="700">
+                <a:solidFill>
+                  <a:srgbClr val="A0B4D2"/>
+                </a:solidFill>
+                <a:latin typeface="Consolas"/>
+              </a:rPr>
+              <a:t>FKB Campus  ·  VA00</a:t>
+            </a:r>
+          </a:p>
+        </p:txBody>
+      </p:sp>
+    </p:spTree>
+  </p:cSld>
+  <p:clrMapOvr>
+    <a:masterClrMapping/>
+  </p:clrMapOvr>
+</p:sld>
+</file>
+
 <file path=ppt/slides/slide2.xml><?xml version="1.0" encoding="utf-8"?>
 <p:sld xmlns:a="http://schemas.openxmlformats.org/drawingml/2006/main" xmlns:p="http://schemas.openxmlformats.org/presentationml/2006/main" xmlns:r="http://schemas.openxmlformats.org/officeDocument/2006/relationships">
   <p:cSld>
@@ -5869,7 +8954,7 @@
             <a:avLst/>
           </a:prstGeom>
           <a:solidFill>
-            <a:srgbClr val="EDEDF3"/>
+            <a:srgbClr val="1F2C56"/>
           </a:solidFill>
           <a:ln>
             <a:noFill/>
@@ -5899,57 +8984,14 @@
       </p:sp>
       <p:sp>
         <p:nvSpPr>
-          <p:cNvPr id="3" name="Rectangle 2"/>
-          <p:cNvSpPr/>
-          <p:nvPr/>
-        </p:nvSpPr>
-        <p:spPr>
-          <a:xfrm>
-            <a:off x="0" y="0"/>
-            <a:ext cx="12188952" cy="50292"/>
-          </a:xfrm>
-          <a:prstGeom prst="rect">
-            <a:avLst/>
-          </a:prstGeom>
-          <a:solidFill>
-            <a:srgbClr val="1F2C56"/>
-          </a:solidFill>
-          <a:ln>
-            <a:noFill/>
-          </a:ln>
-        </p:spPr>
-        <p:style>
-          <a:lnRef idx="1">
-            <a:schemeClr val="accent1"/>
-          </a:lnRef>
-          <a:fillRef idx="3">
-            <a:schemeClr val="accent1"/>
-          </a:fillRef>
-          <a:effectRef idx="2">
-            <a:schemeClr val="accent1"/>
-          </a:effectRef>
-          <a:fontRef idx="minor">
-            <a:schemeClr val="lt1"/>
-          </a:fontRef>
-        </p:style>
-        <p:txBody>
-          <a:bodyPr rtlCol="0" anchor="ctr"/>
-          <a:lstStyle/>
-          <a:p>
-            <a:pPr algn="ctr"/>
-          </a:p>
-        </p:txBody>
-      </p:sp>
-      <p:sp>
-        <p:nvSpPr>
-          <p:cNvPr id="4" name="TextBox 3"/>
+          <p:cNvPr id="3" name="TextBox 2"/>
           <p:cNvSpPr txBox="1"/>
           <p:nvPr/>
         </p:nvSpPr>
         <p:spPr>
           <a:xfrm>
-            <a:off x="685800" y="109728"/>
-            <a:ext cx="10817352" cy="228600"/>
+            <a:off x="685800" y="2377440"/>
+            <a:ext cx="10817352" cy="365760"/>
           </a:xfrm>
           <a:prstGeom prst="rect">
             <a:avLst/>
@@ -5964,70 +9006,27 @@
           <a:p>
             <a:pPr algn="l"/>
             <a:r>
-              <a:rPr sz="750">
-                <a:solidFill>
-                  <a:srgbClr val="78808C"/>
+              <a:rPr sz="1200">
+                <a:solidFill>
+                  <a:srgbClr val="D9C089"/>
                 </a:solidFill>
                 <a:latin typeface="Consolas"/>
               </a:rPr>
-              <a:t>VA00  ·  INHALT</a:t>
-            </a:r>
-          </a:p>
-        </p:txBody>
-      </p:sp>
-      <p:sp>
-        <p:nvSpPr>
-          <p:cNvPr id="5" name="Rectangle 4"/>
+              <a:t>00:05–00:15</a:t>
+            </a:r>
+          </a:p>
+        </p:txBody>
+      </p:sp>
+      <p:sp>
+        <p:nvSpPr>
+          <p:cNvPr id="4" name="Rectangle 3"/>
           <p:cNvSpPr/>
           <p:nvPr/>
         </p:nvSpPr>
         <p:spPr>
           <a:xfrm>
-            <a:off x="0" y="1234440"/>
-            <a:ext cx="12188952" cy="12700"/>
-          </a:xfrm>
-          <a:prstGeom prst="rect">
-            <a:avLst/>
-          </a:prstGeom>
-          <a:solidFill>
-            <a:srgbClr val="D8DFE4"/>
-          </a:solidFill>
-          <a:ln>
-            <a:noFill/>
-          </a:ln>
-        </p:spPr>
-        <p:style>
-          <a:lnRef idx="1">
-            <a:schemeClr val="accent1"/>
-          </a:lnRef>
-          <a:fillRef idx="3">
-            <a:schemeClr val="accent1"/>
-          </a:fillRef>
-          <a:effectRef idx="2">
-            <a:schemeClr val="accent1"/>
-          </a:effectRef>
-          <a:fontRef idx="minor">
-            <a:schemeClr val="lt1"/>
-          </a:fontRef>
-        </p:style>
-        <p:txBody>
-          <a:bodyPr rtlCol="0" anchor="ctr"/>
-          <a:lstStyle/>
-          <a:p>
-            <a:pPr algn="ctr"/>
-          </a:p>
-        </p:txBody>
-      </p:sp>
-      <p:sp>
-        <p:nvSpPr>
-          <p:cNvPr id="6" name="Rectangle 5"/>
-          <p:cNvSpPr/>
-          <p:nvPr/>
-        </p:nvSpPr>
-        <p:spPr>
-          <a:xfrm>
-            <a:off x="685800" y="502920"/>
-            <a:ext cx="36576" cy="658368"/>
+            <a:off x="685800" y="2788920"/>
+            <a:ext cx="548640" cy="38100"/>
           </a:xfrm>
           <a:prstGeom prst="rect">
             <a:avLst/>
@@ -6063,14 +9062,14 @@
       </p:sp>
       <p:sp>
         <p:nvSpPr>
-          <p:cNvPr id="7" name="TextBox 6"/>
+          <p:cNvPr id="5" name="TextBox 4"/>
           <p:cNvSpPr txBox="1"/>
           <p:nvPr/>
         </p:nvSpPr>
         <p:spPr>
           <a:xfrm>
-            <a:off x="813816" y="502920"/>
-            <a:ext cx="10634472" cy="685800"/>
+            <a:off x="685800" y="3017520"/>
+            <a:ext cx="10817352" cy="1463040"/>
           </a:xfrm>
           <a:prstGeom prst="rect">
             <a:avLst/>
@@ -6085,27 +9084,27 @@
           <a:p>
             <a:pPr algn="l"/>
             <a:r>
-              <a:rPr sz="2400" b="1" i="0">
-                <a:solidFill>
-                  <a:srgbClr val="1F2C56"/>
+              <a:rPr sz="4000" b="1" i="0">
+                <a:solidFill>
+                  <a:srgbClr val="FFFFFF"/>
                 </a:solidFill>
                 <a:latin typeface="Arial"/>
               </a:rPr>
-              <a:t>Theorie-Input: Orientierung als professionelle Grundkompetenz</a:t>
-            </a:r>
-          </a:p>
-        </p:txBody>
-      </p:sp>
-      <p:sp>
-        <p:nvSpPr>
-          <p:cNvPr id="8" name="TextBox 7"/>
+              <a:t>Aktivierung</a:t>
+            </a:r>
+          </a:p>
+        </p:txBody>
+      </p:sp>
+      <p:sp>
+        <p:nvSpPr>
+          <p:cNvPr id="6" name="TextBox 5"/>
           <p:cNvSpPr txBox="1"/>
           <p:nvPr/>
         </p:nvSpPr>
         <p:spPr>
           <a:xfrm>
-            <a:off x="685800" y="1417320"/>
-            <a:ext cx="10817352" cy="4892040"/>
+            <a:off x="685800" y="4480560"/>
+            <a:ext cx="8653881" cy="1280160"/>
           </a:xfrm>
           <a:prstGeom prst="rect">
             <a:avLst/>
@@ -6113,103 +9112,34 @@
           <a:noFill/>
         </p:spPr>
         <p:txBody>
-          <a:bodyPr wrap="square" anchor="ctr">
+          <a:bodyPr wrap="square">
             <a:spAutoFit/>
           </a:bodyPr>
           <a:lstStyle/>
           <a:p>
-            <a:pPr marL="190500" indent="-190500">
-              <a:spcBef>
-                <a:spcPts val="400"/>
-              </a:spcBef>
-              <a:spcAft>
-                <a:spcPts val="200"/>
-              </a:spcAft>
-            </a:pPr>
-            <a:r>
-              <a:rPr sz="1300">
-                <a:solidFill>
-                  <a:srgbClr val="3D5466"/>
+            <a:pPr algn="l"/>
+            <a:r>
+              <a:rPr sz="1600" b="0" i="0">
+                <a:solidFill>
+                  <a:srgbClr val="C8D2E6"/>
                 </a:solidFill>
                 <a:latin typeface="Arial"/>
               </a:rPr>
-              <a:t>▸  Vier Orientierungsfelder im Überblick</a:t>
-            </a:r>
-          </a:p>
-          <a:p>
-            <a:pPr marL="190500" indent="-190500">
-              <a:spcBef>
-                <a:spcPts val="400"/>
-              </a:spcBef>
-              <a:spcAft>
-                <a:spcPts val="200"/>
-              </a:spcAft>
-            </a:pPr>
-            <a:r>
-              <a:rPr sz="1300">
-                <a:solidFill>
-                  <a:srgbClr val="3D5466"/>
-                </a:solidFill>
-                <a:latin typeface="Arial"/>
-              </a:rPr>
-              <a:t>▸  Dieses Modul gliedert die Hausorientierung in vier Felder:</a:t>
-            </a:r>
-          </a:p>
-        </p:txBody>
-      </p:sp>
-      <p:sp>
-        <p:nvSpPr>
-          <p:cNvPr id="9" name="Rectangle 8"/>
-          <p:cNvSpPr/>
-          <p:nvPr/>
-        </p:nvSpPr>
-        <p:spPr>
-          <a:xfrm>
-            <a:off x="0" y="6510528"/>
-            <a:ext cx="12188952" cy="347472"/>
-          </a:xfrm>
-          <a:prstGeom prst="rect">
-            <a:avLst/>
-          </a:prstGeom>
-          <a:solidFill>
-            <a:srgbClr val="0A1937"/>
-          </a:solidFill>
-          <a:ln>
-            <a:noFill/>
-          </a:ln>
-        </p:spPr>
-        <p:style>
-          <a:lnRef idx="1">
-            <a:schemeClr val="accent1"/>
-          </a:lnRef>
-          <a:fillRef idx="3">
-            <a:schemeClr val="accent1"/>
-          </a:fillRef>
-          <a:effectRef idx="2">
-            <a:schemeClr val="accent1"/>
-          </a:effectRef>
-          <a:fontRef idx="minor">
-            <a:schemeClr val="lt1"/>
-          </a:fontRef>
-        </p:style>
-        <p:txBody>
-          <a:bodyPr rtlCol="0" anchor="ctr"/>
-          <a:lstStyle/>
-          <a:p>
-            <a:pPr algn="ctr"/>
-          </a:p>
-        </p:txBody>
-      </p:sp>
-      <p:sp>
-        <p:nvSpPr>
-          <p:cNvPr id="10" name="TextBox 9"/>
+              <a:t>Was weiß ich schon? Die eigene Landkarte beginnt mit dem, was Sie kennen.</a:t>
+            </a:r>
+          </a:p>
+        </p:txBody>
+      </p:sp>
+      <p:sp>
+        <p:nvSpPr>
+          <p:cNvPr id="7" name="TextBox 6"/>
           <p:cNvSpPr txBox="1"/>
           <p:nvPr/>
         </p:nvSpPr>
         <p:spPr>
           <a:xfrm>
-            <a:off x="685800" y="6583680"/>
-            <a:ext cx="6490411" cy="256032"/>
+            <a:off x="685800" y="6355080"/>
+            <a:ext cx="10817352" cy="274320"/>
           </a:xfrm>
           <a:prstGeom prst="rect">
             <a:avLst/>
@@ -6226,7 +9156,7 @@
             <a:r>
               <a:rPr sz="700">
                 <a:solidFill>
-                  <a:srgbClr val="A0B4D2"/>
+                  <a:srgbClr val="8CA0C3"/>
                 </a:solidFill>
                 <a:latin typeface="Consolas"/>
               </a:rPr>
@@ -6490,7 +9420,7 @@
                 </a:solidFill>
                 <a:latin typeface="Arial"/>
               </a:rPr>
-              <a:t>Theorie-Input: Die vier Orientierungsfelder im Detail</a:t>
+              <a:t>Die vier Orientierungsfelder</a:t>
             </a:r>
           </a:p>
         </p:txBody>
@@ -6512,27 +9442,27 @@
           <a:noFill/>
         </p:spPr>
         <p:txBody>
-          <a:bodyPr wrap="square">
+          <a:bodyPr wrap="square" anchor="ctr">
             <a:spAutoFit/>
           </a:bodyPr>
           <a:lstStyle/>
           <a:p>
-            <a:pPr>
+            <a:pPr marL="177800" indent="-177800">
               <a:spcBef>
-                <a:spcPts val="1000"/>
+                <a:spcPts val="600"/>
               </a:spcBef>
               <a:spcAft>
                 <a:spcPts val="200"/>
               </a:spcAft>
             </a:pPr>
             <a:r>
-              <a:rPr sz="800" b="1">
-                <a:solidFill>
-                  <a:srgbClr val="78808C"/>
-                </a:solidFill>
-                <a:latin typeface="Consolas"/>
-              </a:rPr>
-              <a:t>FELD 1 – PRODUKTE &amp; VERBUND: WAS GIBT ES, WER IST ZUSTÄNDIG</a:t>
+              <a:rPr sz="1200" i="1">
+                <a:solidFill>
+                  <a:srgbClr val="3D5466"/>
+                </a:solidFill>
+                <a:latin typeface="Arial"/>
+              </a:rPr>
+              <a:t>→  Sie müssen das noch nicht beherrschen – Sie müssen wissen, was es gibt und wo Sie sich einordnen.</a:t>
             </a:r>
           </a:p>
           <a:p>
@@ -6551,7 +9481,7 @@
                 </a:solidFill>
                 <a:latin typeface="Arial"/>
               </a:rPr>
-              <a:t>▸  Produktgruppen im Überblick:</a:t>
+              <a:t>▸  Produkte &amp; Verbund: Was bieten wir an, und wer im Verbund hilft dabei?</a:t>
             </a:r>
           </a:p>
           <a:p>
@@ -6570,26 +9500,7 @@
                 </a:solidFill>
                 <a:latin typeface="Arial"/>
               </a:rPr>
-              <a:t>▸  Verbundpartner und -dienstleister der genossenschaftlichen FinanzGruppe:</a:t>
-            </a:r>
-          </a:p>
-          <a:p>
-            <a:pPr>
-              <a:spcBef>
-                <a:spcPts val="1000"/>
-              </a:spcBef>
-              <a:spcAft>
-                <a:spcPts val="200"/>
-              </a:spcAft>
-            </a:pPr>
-            <a:r>
-              <a:rPr sz="800" b="1">
-                <a:solidFill>
-                  <a:srgbClr val="78808C"/>
-                </a:solidFill>
-                <a:latin typeface="Consolas"/>
-              </a:rPr>
-              <a:t>FELD 2 – PROZESSE &amp; ROLLEN: DER KREDITPROZESS END-TO-END</a:t>
+              <a:t>▸  Prozesse &amp; Rollen: Wer entscheidet was – und wo stehe ich darin?</a:t>
             </a:r>
           </a:p>
           <a:p>
@@ -6608,64 +9519,7 @@
                 </a:solidFill>
                 <a:latin typeface="Arial"/>
               </a:rPr>
-              <a:t>▸  Kreditprozess im Überblick (vereinfacht):</a:t>
-            </a:r>
-          </a:p>
-          <a:p>
-            <a:pPr marL="177800" indent="-177800">
-              <a:spcBef>
-                <a:spcPts val="600"/>
-              </a:spcBef>
-              <a:spcAft>
-                <a:spcPts val="200"/>
-              </a:spcAft>
-            </a:pPr>
-            <a:r>
-              <a:rPr sz="1200" i="1">
-                <a:solidFill>
-                  <a:srgbClr val="3D5466"/>
-                </a:solidFill>
-                <a:latin typeface="Arial"/>
-              </a:rPr>
-              <a:t>→  Handlungsempfehlung</a:t>
-            </a:r>
-          </a:p>
-          <a:p>
-            <a:pPr marL="177800" indent="-177800">
-              <a:spcBef>
-                <a:spcPts val="600"/>
-              </a:spcBef>
-              <a:spcAft>
-                <a:spcPts val="200"/>
-              </a:spcAft>
-            </a:pPr>
-            <a:r>
-              <a:rPr sz="1200" i="1">
-                <a:solidFill>
-                  <a:srgbClr val="3D5466"/>
-                </a:solidFill>
-                <a:latin typeface="Arial"/>
-              </a:rPr>
-              <a:t>→  Wenn Sie unsicher sind, ob eine Aufgabe (z. B. das Votum zu einem Kreditbeschluss) dem Markt oder der Marktfolge zufällt</a:t>
-            </a:r>
-          </a:p>
-          <a:p>
-            <a:pPr>
-              <a:spcBef>
-                <a:spcPts val="1000"/>
-              </a:spcBef>
-              <a:spcAft>
-                <a:spcPts val="200"/>
-              </a:spcAft>
-            </a:pPr>
-            <a:r>
-              <a:rPr sz="800" b="1">
-                <a:solidFill>
-                  <a:srgbClr val="78808C"/>
-                </a:solidFill>
-                <a:latin typeface="Consolas"/>
-              </a:rPr>
-              <a:t>FELD 3 – TECHNISCHE SYSTEME: WELCHES SYSTEM WOFÜR</a:t>
+              <a:t>▸  Technische Systeme: Welches System nutze ich wofür?</a:t>
             </a:r>
           </a:p>
           <a:p>
@@ -6684,64 +9538,7 @@
                 </a:solidFill>
                 <a:latin typeface="Arial"/>
               </a:rPr>
-              <a:t>▸  Im Innendienst arbeiten Sie täglich mit mehreren digitalen Werkzeugen. Eine klare mentale Zuordnung (welches System wofür) vermeidet Doppelarbeit und Fehler.</a:t>
-            </a:r>
-          </a:p>
-          <a:p>
-            <a:pPr marL="190500" indent="-190500">
-              <a:spcBef>
-                <a:spcPts val="400"/>
-              </a:spcBef>
-              <a:spcAft>
-                <a:spcPts val="200"/>
-              </a:spcAft>
-            </a:pPr>
-            <a:r>
-              <a:rPr sz="1300">
-                <a:solidFill>
-                  <a:srgbClr val="3D5466"/>
-                </a:solidFill>
-                <a:latin typeface="Arial"/>
-              </a:rPr>
-              <a:t>▸  Systemlandschaft im Überblick:</a:t>
-            </a:r>
-          </a:p>
-          <a:p>
-            <a:pPr>
-              <a:spcBef>
-                <a:spcPts val="1000"/>
-              </a:spcBef>
-              <a:spcAft>
-                <a:spcPts val="200"/>
-              </a:spcAft>
-            </a:pPr>
-            <a:r>
-              <a:rPr sz="800" b="1">
-                <a:solidFill>
-                  <a:srgbClr val="78808C"/>
-                </a:solidFill>
-                <a:latin typeface="Consolas"/>
-              </a:rPr>
-              <a:t>FELD 4 – ERWARTUNGEN &amp; SCHNITTSTELLEN: WER ERWARTET WAS</a:t>
-            </a:r>
-          </a:p>
-          <a:p>
-            <a:pPr marL="190500" indent="-190500">
-              <a:spcBef>
-                <a:spcPts val="400"/>
-              </a:spcBef>
-              <a:spcAft>
-                <a:spcPts val="200"/>
-              </a:spcAft>
-            </a:pPr>
-            <a:r>
-              <a:rPr sz="1300">
-                <a:solidFill>
-                  <a:srgbClr val="3D5466"/>
-                </a:solidFill>
-                <a:latin typeface="Arial"/>
-              </a:rPr>
-              <a:t>▸  Typische Erwartungen der Berater an die Assistenz:</a:t>
+              <a:t>▸  Erwartungen &amp; Schnittstellen: Was braucht mein Berater von mir – und wen frage ich bei was?</a:t>
             </a:r>
           </a:p>
         </p:txBody>
@@ -6958,7 +9755,7 @@
                 </a:solidFill>
                 <a:latin typeface="Consolas"/>
               </a:rPr>
-              <a:t>VA00  ·  ÜBERSICHT</a:t>
+              <a:t>VA00  ·  SCHAUBILD</a:t>
             </a:r>
           </a:p>
         </p:txBody>
@@ -6993,7 +9790,7 @@
                 </a:solidFill>
                 <a:latin typeface="Arial"/>
               </a:rPr>
-              <a:t>Theorie-Input: Die vier Orientierungsfelder im Detail</a:t>
+              <a:t>Die Landkarte des eigenen Hauses</a:t>
             </a:r>
           </a:p>
         </p:txBody>
@@ -7041,381 +9838,30 @@
           </a:p>
         </p:txBody>
       </p:sp>
-      <p:graphicFrame>
-        <p:nvGraphicFramePr>
-          <p:cNvPr id="7" name="Table 6"/>
-          <p:cNvGraphicFramePr>
-            <a:graphicFrameLocks noGrp="1"/>
-          </p:cNvGraphicFramePr>
-          <p:nvPr/>
-        </p:nvGraphicFramePr>
-        <p:xfrm>
-          <a:off x="685800" y="1417320"/>
-          <a:ext cx="10817352" cy="2304288"/>
-        </p:xfrm>
-        <a:graphic>
-          <a:graphicData uri="http://schemas.openxmlformats.org/drawingml/2006/table">
-            <a:tbl>
-              <a:tblPr firstRow="1" bandRow="1">
-                <a:tableStyleId>{5C22544A-7EE6-4342-B048-85BDC9FD1C3A}</a:tableStyleId>
-              </a:tblPr>
-              <a:tblGrid>
-                <a:gridCol w="3605784"/>
-                <a:gridCol w="3605784"/>
-                <a:gridCol w="3605784"/>
-              </a:tblGrid>
-              <a:tr h="384048">
-                <a:tc>
-                  <a:txBody>
-                    <a:bodyPr/>
-                    <a:lstStyle/>
-                    <a:p>
-                      <a:r>
-                        <a:rPr sz="1100" b="1">
-                          <a:solidFill>
-                            <a:srgbClr val="FFFFFF"/>
-                          </a:solidFill>
-                          <a:latin typeface="Arial"/>
-                        </a:rPr>
-                        <a:t>Stelle</a:t>
-                      </a:r>
-                    </a:p>
-                  </a:txBody>
-                  <a:tcPr>
-                    <a:solidFill>
-                      <a:srgbClr val="1F2C56"/>
-                    </a:solidFill>
-                  </a:tcPr>
-                </a:tc>
-                <a:tc>
-                  <a:txBody>
-                    <a:bodyPr/>
-                    <a:lstStyle/>
-                    <a:p>
-                      <a:r>
-                        <a:rPr sz="1100" b="1">
-                          <a:solidFill>
-                            <a:srgbClr val="FFFFFF"/>
-                          </a:solidFill>
-                          <a:latin typeface="Arial"/>
-                        </a:rPr>
-                        <a:t>Funktion</a:t>
-                      </a:r>
-                    </a:p>
-                  </a:txBody>
-                  <a:tcPr>
-                    <a:solidFill>
-                      <a:srgbClr val="1F2C56"/>
-                    </a:solidFill>
-                  </a:tcPr>
-                </a:tc>
-                <a:tc>
-                  <a:txBody>
-                    <a:bodyPr/>
-                    <a:lstStyle/>
-                    <a:p>
-                      <a:r>
-                        <a:rPr sz="1100" b="1">
-                          <a:solidFill>
-                            <a:srgbClr val="FFFFFF"/>
-                          </a:solidFill>
-                          <a:latin typeface="Arial"/>
-                        </a:rPr>
-                        <a:t>Typischer Kontaktanlass</a:t>
-                      </a:r>
-                    </a:p>
-                  </a:txBody>
-                  <a:tcPr>
-                    <a:solidFill>
-                      <a:srgbClr val="1F2C56"/>
-                    </a:solidFill>
-                  </a:tcPr>
-                </a:tc>
-              </a:tr>
-              <a:tr h="384048">
-                <a:tc>
-                  <a:txBody>
-                    <a:bodyPr/>
-                    <a:lstStyle/>
-                    <a:p>
-                      <a:r>
-                        <a:rPr sz="1050">
-                          <a:solidFill>
-                            <a:srgbClr val="3D5466"/>
-                          </a:solidFill>
-                          <a:latin typeface="Arial"/>
-                        </a:rPr>
-                        <a:t>Marktfolge</a:t>
-                      </a:r>
-                    </a:p>
-                  </a:txBody>
-                  <a:tcPr/>
-                </a:tc>
-                <a:tc>
-                  <a:txBody>
-                    <a:bodyPr/>
-                    <a:lstStyle/>
-                    <a:p>
-                      <a:r>
-                        <a:rPr sz="1050">
-                          <a:solidFill>
-                            <a:srgbClr val="3D5466"/>
-                          </a:solidFill>
-                          <a:latin typeface="Arial"/>
-                        </a:rPr>
-                        <a:t>Kreditanalyse, Votum, Bestandsbearbeitung</a:t>
-                      </a:r>
-                    </a:p>
-                  </a:txBody>
-                  <a:tcPr/>
-                </a:tc>
-                <a:tc>
-                  <a:txBody>
-                    <a:bodyPr/>
-                    <a:lstStyle/>
-                    <a:p>
-                      <a:r>
-                        <a:rPr sz="1050">
-                          <a:solidFill>
-                            <a:srgbClr val="3D5466"/>
-                          </a:solidFill>
-                          <a:latin typeface="Arial"/>
-                        </a:rPr>
-                        <a:t>Vollständigkeit der Akte, Offenlegungsfristen</a:t>
-                      </a:r>
-                    </a:p>
-                  </a:txBody>
-                  <a:tcPr/>
-                </a:tc>
-              </a:tr>
-              <a:tr h="384048">
-                <a:tc>
-                  <a:txBody>
-                    <a:bodyPr/>
-                    <a:lstStyle/>
-                    <a:p>
-                      <a:r>
-                        <a:rPr sz="1050">
-                          <a:solidFill>
-                            <a:srgbClr val="3D5466"/>
-                          </a:solidFill>
-                          <a:latin typeface="Arial"/>
-                        </a:rPr>
-                        <a:t>Rechtsabteilung</a:t>
-                      </a:r>
-                    </a:p>
-                  </a:txBody>
-                  <a:tcPr/>
-                </a:tc>
-                <a:tc>
-                  <a:txBody>
-                    <a:bodyPr/>
-                    <a:lstStyle/>
-                    <a:p>
-                      <a:r>
-                        <a:rPr sz="1050">
-                          <a:solidFill>
-                            <a:srgbClr val="3D5466"/>
-                          </a:solidFill>
-                          <a:latin typeface="Arial"/>
-                        </a:rPr>
-                        <a:t>Vertragsrecht, Sicherheitenrecht</a:t>
-                      </a:r>
-                    </a:p>
-                  </a:txBody>
-                  <a:tcPr/>
-                </a:tc>
-                <a:tc>
-                  <a:txBody>
-                    <a:bodyPr/>
-                    <a:lstStyle/>
-                    <a:p>
-                      <a:r>
-                        <a:rPr sz="1050">
-                          <a:solidFill>
-                            <a:srgbClr val="3D5466"/>
-                          </a:solidFill>
-                          <a:latin typeface="Arial"/>
-                        </a:rPr>
-                        <a:t>Fragen zu Sicherheitenverträgen, Vollmachten</a:t>
-                      </a:r>
-                    </a:p>
-                  </a:txBody>
-                  <a:tcPr/>
-                </a:tc>
-              </a:tr>
-              <a:tr h="384048">
-                <a:tc>
-                  <a:txBody>
-                    <a:bodyPr/>
-                    <a:lstStyle/>
-                    <a:p>
-                      <a:r>
-                        <a:rPr sz="1050">
-                          <a:solidFill>
-                            <a:srgbClr val="3D5466"/>
-                          </a:solidFill>
-                          <a:latin typeface="Arial"/>
-                        </a:rPr>
-                        <a:t>IT-Koordinator</a:t>
-                      </a:r>
-                    </a:p>
-                  </a:txBody>
-                  <a:tcPr/>
-                </a:tc>
-                <a:tc>
-                  <a:txBody>
-                    <a:bodyPr/>
-                    <a:lstStyle/>
-                    <a:p>
-                      <a:r>
-                        <a:rPr sz="1050">
-                          <a:solidFill>
-                            <a:srgbClr val="3D5466"/>
-                          </a:solidFill>
-                          <a:latin typeface="Arial"/>
-                        </a:rPr>
-                        <a:t>Systemzugang, agree-Berechtigungen</a:t>
-                      </a:r>
-                    </a:p>
-                  </a:txBody>
-                  <a:tcPr/>
-                </a:tc>
-                <a:tc>
-                  <a:txBody>
-                    <a:bodyPr/>
-                    <a:lstStyle/>
-                    <a:p>
-                      <a:r>
-                        <a:rPr sz="1050">
-                          <a:solidFill>
-                            <a:srgbClr val="3D5466"/>
-                          </a:solidFill>
-                          <a:latin typeface="Arial"/>
-                        </a:rPr>
-                        <a:t>Neue Zugänge, Systemfehler</a:t>
-                      </a:r>
-                    </a:p>
-                  </a:txBody>
-                  <a:tcPr/>
-                </a:tc>
-              </a:tr>
-              <a:tr h="384048">
-                <a:tc>
-                  <a:txBody>
-                    <a:bodyPr/>
-                    <a:lstStyle/>
-                    <a:p>
-                      <a:r>
-                        <a:rPr sz="1050">
-                          <a:solidFill>
-                            <a:srgbClr val="3D5466"/>
-                          </a:solidFill>
-                          <a:latin typeface="Arial"/>
-                        </a:rPr>
-                        <a:t>Verbundspezialisten</a:t>
-                      </a:r>
-                    </a:p>
-                  </a:txBody>
-                  <a:tcPr/>
-                </a:tc>
-                <a:tc>
-                  <a:txBody>
-                    <a:bodyPr/>
-                    <a:lstStyle/>
-                    <a:p>
-                      <a:r>
-                        <a:rPr sz="1050">
-                          <a:solidFill>
-                            <a:srgbClr val="3D5466"/>
-                          </a:solidFill>
-                          <a:latin typeface="Arial"/>
-                        </a:rPr>
-                        <a:t>R+V, Union, Schwäbisch Hall etc.</a:t>
-                      </a:r>
-                    </a:p>
-                  </a:txBody>
-                  <a:tcPr/>
-                </a:tc>
-                <a:tc>
-                  <a:txBody>
-                    <a:bodyPr/>
-                    <a:lstStyle/>
-                    <a:p>
-                      <a:r>
-                        <a:rPr sz="1050">
-                          <a:solidFill>
-                            <a:srgbClr val="3D5466"/>
-                          </a:solidFill>
-                          <a:latin typeface="Arial"/>
-                        </a:rPr>
-                        <a:t>Weiterleitung von Kundenanfragen</a:t>
-                      </a:r>
-                    </a:p>
-                  </a:txBody>
-                  <a:tcPr/>
-                </a:tc>
-              </a:tr>
-              <a:tr h="384048">
-                <a:tc>
-                  <a:txBody>
-                    <a:bodyPr/>
-                    <a:lstStyle/>
-                    <a:p>
-                      <a:r>
-                        <a:rPr sz="1050">
-                          <a:solidFill>
-                            <a:srgbClr val="3D5466"/>
-                          </a:solidFill>
-                          <a:latin typeface="Arial"/>
-                        </a:rPr>
-                        <a:t>Innendienst-Kolleg:innen</a:t>
-                      </a:r>
-                    </a:p>
-                  </a:txBody>
-                  <a:tcPr/>
-                </a:tc>
-                <a:tc>
-                  <a:txBody>
-                    <a:bodyPr/>
-                    <a:lstStyle/>
-                    <a:p>
-                      <a:r>
-                        <a:rPr sz="1050">
-                          <a:solidFill>
-                            <a:srgbClr val="3D5466"/>
-                          </a:solidFill>
-                          <a:latin typeface="Arial"/>
-                        </a:rPr>
-                        <a:t>Kollegen im selben Bereich</a:t>
-                      </a:r>
-                    </a:p>
-                  </a:txBody>
-                  <a:tcPr/>
-                </a:tc>
-                <a:tc>
-                  <a:txBody>
-                    <a:bodyPr/>
-                    <a:lstStyle/>
-                    <a:p>
-                      <a:r>
-                        <a:rPr sz="1050">
-                          <a:solidFill>
-                            <a:srgbClr val="3D5466"/>
-                          </a:solidFill>
-                          <a:latin typeface="Arial"/>
-                        </a:rPr>
-                        <a:t>Urlaubsvertretung, Fachfragen</a:t>
-                      </a:r>
-                    </a:p>
-                  </a:txBody>
-                  <a:tcPr/>
-                </a:tc>
-              </a:tr>
-            </a:tbl>
-          </a:graphicData>
-        </a:graphic>
-      </p:graphicFrame>
+      <p:pic>
+        <p:nvPicPr>
+          <p:cNvPr id="7" name="Picture 6" descr="image.png"/>
+          <p:cNvPicPr>
+            <a:picLocks noChangeAspect="1"/>
+          </p:cNvPicPr>
+          <p:nvPr/>
+        </p:nvPicPr>
+        <p:blipFill>
+          <a:blip r:embed="rId2"/>
+          <a:stretch>
+            <a:fillRect/>
+          </a:stretch>
+        </p:blipFill>
+        <p:spPr>
+          <a:xfrm>
+            <a:off x="2009463" y="1325880"/>
+            <a:ext cx="8170026" cy="4937760"/>
+          </a:xfrm>
+          <a:prstGeom prst="rect">
+            <a:avLst/>
+          </a:prstGeom>
+        </p:spPr>
+      </p:pic>
       <p:sp>
         <p:nvSpPr>
           <p:cNvPr id="8" name="Rectangle 7"/>
@@ -7524,7 +9970,7 @@
                 </a:solidFill>
                 <a:latin typeface="Consolas"/>
               </a:rPr>
-              <a:t>Übersicht</a:t>
+              <a:t>Schaubild</a:t>
             </a:r>
           </a:p>
         </p:txBody>
@@ -7562,7 +10008,7 @@
             <a:avLst/>
           </a:prstGeom>
           <a:solidFill>
-            <a:srgbClr val="EDEDF3"/>
+            <a:srgbClr val="1F2C56"/>
           </a:solidFill>
           <a:ln>
             <a:noFill/>
@@ -7592,57 +10038,14 @@
       </p:sp>
       <p:sp>
         <p:nvSpPr>
-          <p:cNvPr id="3" name="Rectangle 2"/>
-          <p:cNvSpPr/>
-          <p:nvPr/>
-        </p:nvSpPr>
-        <p:spPr>
-          <a:xfrm>
-            <a:off x="0" y="0"/>
-            <a:ext cx="12188952" cy="50292"/>
-          </a:xfrm>
-          <a:prstGeom prst="rect">
-            <a:avLst/>
-          </a:prstGeom>
-          <a:solidFill>
-            <a:srgbClr val="1F2C56"/>
-          </a:solidFill>
-          <a:ln>
-            <a:noFill/>
-          </a:ln>
-        </p:spPr>
-        <p:style>
-          <a:lnRef idx="1">
-            <a:schemeClr val="accent1"/>
-          </a:lnRef>
-          <a:fillRef idx="3">
-            <a:schemeClr val="accent1"/>
-          </a:fillRef>
-          <a:effectRef idx="2">
-            <a:schemeClr val="accent1"/>
-          </a:effectRef>
-          <a:fontRef idx="minor">
-            <a:schemeClr val="lt1"/>
-          </a:fontRef>
-        </p:style>
-        <p:txBody>
-          <a:bodyPr rtlCol="0" anchor="ctr"/>
-          <a:lstStyle/>
-          <a:p>
-            <a:pPr algn="ctr"/>
-          </a:p>
-        </p:txBody>
-      </p:sp>
-      <p:sp>
-        <p:nvSpPr>
-          <p:cNvPr id="4" name="TextBox 3"/>
+          <p:cNvPr id="3" name="TextBox 2"/>
           <p:cNvSpPr txBox="1"/>
           <p:nvPr/>
         </p:nvSpPr>
         <p:spPr>
           <a:xfrm>
-            <a:off x="685800" y="109728"/>
-            <a:ext cx="10817352" cy="228600"/>
+            <a:off x="685800" y="2377440"/>
+            <a:ext cx="10817352" cy="365760"/>
           </a:xfrm>
           <a:prstGeom prst="rect">
             <a:avLst/>
@@ -7657,70 +10060,27 @@
           <a:p>
             <a:pPr algn="l"/>
             <a:r>
-              <a:rPr sz="750">
-                <a:solidFill>
-                  <a:srgbClr val="78808C"/>
+              <a:rPr sz="1200">
+                <a:solidFill>
+                  <a:srgbClr val="D9C089"/>
                 </a:solidFill>
                 <a:latin typeface="Consolas"/>
               </a:rPr>
-              <a:t>VA00  ·  ARBEITSBLATT</a:t>
-            </a:r>
-          </a:p>
-        </p:txBody>
-      </p:sp>
-      <p:sp>
-        <p:nvSpPr>
-          <p:cNvPr id="5" name="Rectangle 4"/>
+              <a:t>00:15–00:30</a:t>
+            </a:r>
+          </a:p>
+        </p:txBody>
+      </p:sp>
+      <p:sp>
+        <p:nvSpPr>
+          <p:cNvPr id="4" name="Rectangle 3"/>
           <p:cNvSpPr/>
           <p:nvPr/>
         </p:nvSpPr>
         <p:spPr>
           <a:xfrm>
-            <a:off x="0" y="1234440"/>
-            <a:ext cx="12188952" cy="12700"/>
-          </a:xfrm>
-          <a:prstGeom prst="rect">
-            <a:avLst/>
-          </a:prstGeom>
-          <a:solidFill>
-            <a:srgbClr val="D8DFE4"/>
-          </a:solidFill>
-          <a:ln>
-            <a:noFill/>
-          </a:ln>
-        </p:spPr>
-        <p:style>
-          <a:lnRef idx="1">
-            <a:schemeClr val="accent1"/>
-          </a:lnRef>
-          <a:fillRef idx="3">
-            <a:schemeClr val="accent1"/>
-          </a:fillRef>
-          <a:effectRef idx="2">
-            <a:schemeClr val="accent1"/>
-          </a:effectRef>
-          <a:fontRef idx="minor">
-            <a:schemeClr val="lt1"/>
-          </a:fontRef>
-        </p:style>
-        <p:txBody>
-          <a:bodyPr rtlCol="0" anchor="ctr"/>
-          <a:lstStyle/>
-          <a:p>
-            <a:pPr algn="ctr"/>
-          </a:p>
-        </p:txBody>
-      </p:sp>
-      <p:sp>
-        <p:nvSpPr>
-          <p:cNvPr id="6" name="Rectangle 5"/>
-          <p:cNvSpPr/>
-          <p:nvPr/>
-        </p:nvSpPr>
-        <p:spPr>
-          <a:xfrm>
-            <a:off x="685800" y="502920"/>
-            <a:ext cx="36576" cy="658368"/>
+            <a:off x="685800" y="2788920"/>
+            <a:ext cx="548640" cy="38100"/>
           </a:xfrm>
           <a:prstGeom prst="rect">
             <a:avLst/>
@@ -7756,14 +10116,14 @@
       </p:sp>
       <p:sp>
         <p:nvSpPr>
-          <p:cNvPr id="7" name="TextBox 6"/>
+          <p:cNvPr id="5" name="TextBox 4"/>
           <p:cNvSpPr txBox="1"/>
           <p:nvPr/>
         </p:nvSpPr>
         <p:spPr>
           <a:xfrm>
-            <a:off x="813816" y="502920"/>
-            <a:ext cx="10634472" cy="685800"/>
+            <a:off x="685800" y="3017520"/>
+            <a:ext cx="10817352" cy="1463040"/>
           </a:xfrm>
           <a:prstGeom prst="rect">
             <a:avLst/>
@@ -7778,27 +10138,27 @@
           <a:p>
             <a:pPr algn="l"/>
             <a:r>
-              <a:rPr sz="2400" b="1" i="0">
-                <a:solidFill>
-                  <a:srgbClr val="1F2C56"/>
+              <a:rPr sz="4000" b="1" i="0">
+                <a:solidFill>
+                  <a:srgbClr val="FFFFFF"/>
                 </a:solidFill>
                 <a:latin typeface="Arial"/>
               </a:rPr>
-              <a:t>Praxisfall: Erste Wochen im Firmenkunden-Innendienst</a:t>
-            </a:r>
-          </a:p>
-        </p:txBody>
-      </p:sp>
-      <p:sp>
-        <p:nvSpPr>
-          <p:cNvPr id="8" name="TextBox 7"/>
+              <a:t>Feld 1 &amp; 2</a:t>
+            </a:r>
+          </a:p>
+        </p:txBody>
+      </p:sp>
+      <p:sp>
+        <p:nvSpPr>
+          <p:cNvPr id="6" name="TextBox 5"/>
           <p:cNvSpPr txBox="1"/>
           <p:nvPr/>
         </p:nvSpPr>
         <p:spPr>
           <a:xfrm>
-            <a:off x="685800" y="1554480"/>
-            <a:ext cx="10817352" cy="3840480"/>
+            <a:off x="685800" y="4480560"/>
+            <a:ext cx="8653881" cy="1280160"/>
           </a:xfrm>
           <a:prstGeom prst="rect">
             <a:avLst/>
@@ -7811,233 +10171,29 @@
           </a:bodyPr>
           <a:lstStyle/>
           <a:p>
-            <a:pPr marL="190500" indent="-190500">
-              <a:spcBef>
-                <a:spcPts val="400"/>
-              </a:spcBef>
-              <a:spcAft>
-                <a:spcPts val="200"/>
-              </a:spcAft>
-            </a:pPr>
-            <a:r>
-              <a:rPr sz="1400">
-                <a:solidFill>
-                  <a:srgbClr val="3D5466"/>
+            <a:pPr algn="l"/>
+            <a:r>
+              <a:rPr sz="1600" b="0" i="0">
+                <a:solidFill>
+                  <a:srgbClr val="C8D2E6"/>
                 </a:solidFill>
                 <a:latin typeface="Arial"/>
               </a:rPr>
-              <a:t>▸  Ausgangslage (anonymisiert, branchentypisch)</a:t>
-            </a:r>
-          </a:p>
-          <a:p>
-            <a:pPr marL="190500" indent="-190500">
-              <a:spcBef>
-                <a:spcPts val="400"/>
-              </a:spcBef>
-              <a:spcAft>
-                <a:spcPts val="200"/>
-              </a:spcAft>
-            </a:pPr>
-            <a:r>
-              <a:rPr sz="1400">
-                <a:solidFill>
-                  <a:srgbClr val="3D5466"/>
-                </a:solidFill>
-                <a:latin typeface="Arial"/>
-              </a:rPr>
-              <a:t>▸  Am ersten Arbeitstag landet in ihrer Aufgabenliste in agree:</a:t>
-            </a:r>
-          </a:p>
-          <a:p>
-            <a:pPr marL="190500" indent="-190500">
-              <a:spcBef>
-                <a:spcPts val="400"/>
-              </a:spcBef>
-              <a:spcAft>
-                <a:spcPts val="200"/>
-              </a:spcAft>
-            </a:pPr>
-            <a:r>
-              <a:rPr sz="1400">
-                <a:solidFill>
-                  <a:srgbClr val="3D5466"/>
-                </a:solidFill>
-                <a:latin typeface="Arial"/>
-              </a:rPr>
-              <a:t>▸  Unterlagen für die laufende Offenlegung bei der Maschinen Musterregion GmbH (Umsatz 4,2 Mio. EUR, 22 Mitarbeiter) anfordern – Jahresabschluss 2024 noch nicht eingegangen.</a:t>
-            </a:r>
-          </a:p>
-          <a:p>
-            <a:pPr marL="190500" indent="-190500">
-              <a:spcBef>
-                <a:spcPts val="400"/>
-              </a:spcBef>
-              <a:spcAft>
-                <a:spcPts val="200"/>
-              </a:spcAft>
-            </a:pPr>
-            <a:r>
-              <a:rPr sz="1400">
-                <a:solidFill>
-                  <a:srgbClr val="3D5466"/>
-                </a:solidFill>
-                <a:latin typeface="Arial"/>
-              </a:rPr>
-              <a:t>▸  Eine neue Geschäftsadresse für Bau Musterregion KG dokumentieren.</a:t>
-            </a:r>
-          </a:p>
-          <a:p>
-            <a:pPr marL="190500" indent="-190500">
-              <a:spcBef>
-                <a:spcPts val="400"/>
-              </a:spcBef>
-              <a:spcAft>
-                <a:spcPts val="200"/>
-              </a:spcAft>
-            </a:pPr>
-            <a:r>
-              <a:rPr sz="1400">
-                <a:solidFill>
-                  <a:srgbClr val="3D5466"/>
-                </a:solidFill>
-                <a:latin typeface="Arial"/>
-              </a:rPr>
-              <a:t>▸  Ein Beratungsgespräch für den nächsten Dienstag vorbereiten – Einladung an den Kunden versenden.</a:t>
-            </a:r>
-          </a:p>
-        </p:txBody>
-      </p:sp>
-      <p:sp>
-        <p:nvSpPr>
-          <p:cNvPr id="9" name="Rectangle 8"/>
-          <p:cNvSpPr/>
-          <p:nvPr/>
-        </p:nvSpPr>
-        <p:spPr>
-          <a:xfrm>
-            <a:off x="685800" y="5486400"/>
-            <a:ext cx="10817352" cy="640080"/>
-          </a:xfrm>
-          <a:prstGeom prst="rect">
-            <a:avLst/>
-          </a:prstGeom>
-          <a:solidFill>
-            <a:srgbClr val="1F2C56"/>
-          </a:solidFill>
-          <a:ln>
-            <a:noFill/>
-          </a:ln>
-        </p:spPr>
-        <p:style>
-          <a:lnRef idx="1">
-            <a:schemeClr val="accent1"/>
-          </a:lnRef>
-          <a:fillRef idx="3">
-            <a:schemeClr val="accent1"/>
-          </a:fillRef>
-          <a:effectRef idx="2">
-            <a:schemeClr val="accent1"/>
-          </a:effectRef>
-          <a:fontRef idx="minor">
-            <a:schemeClr val="lt1"/>
-          </a:fontRef>
-        </p:style>
-        <p:txBody>
-          <a:bodyPr rtlCol="0" anchor="ctr"/>
-          <a:lstStyle/>
-          <a:p>
-            <a:pPr algn="ctr"/>
-          </a:p>
-        </p:txBody>
-      </p:sp>
-      <p:sp>
-        <p:nvSpPr>
-          <p:cNvPr id="10" name="TextBox 9"/>
+              <a:t>Produkte und Verbund kennen – und den Kreditprozess mit seinen Rollen.</a:t>
+            </a:r>
+          </a:p>
+        </p:txBody>
+      </p:sp>
+      <p:sp>
+        <p:nvSpPr>
+          <p:cNvPr id="7" name="TextBox 6"/>
           <p:cNvSpPr txBox="1"/>
           <p:nvPr/>
         </p:nvSpPr>
         <p:spPr>
           <a:xfrm>
-            <a:off x="868680" y="5596128"/>
-            <a:ext cx="10451592" cy="457200"/>
-          </a:xfrm>
-          <a:prstGeom prst="rect">
-            <a:avLst/>
-          </a:prstGeom>
-          <a:noFill/>
-        </p:spPr>
-        <p:txBody>
-          <a:bodyPr wrap="square">
-            <a:spAutoFit/>
-          </a:bodyPr>
-          <a:lstStyle/>
-          <a:p>
-            <a:pPr algn="l"/>
-            <a:r>
-              <a:rPr sz="1300" b="1" i="0">
-                <a:solidFill>
-                  <a:srgbClr val="FFFFFF"/>
-                </a:solidFill>
-                <a:latin typeface="Arial"/>
-              </a:rPr>
-              <a:t>→  Bearbeitung im Teilnehmer-Workbook (Arbeitsblatt mit Ausfüllfeldern)</a:t>
-            </a:r>
-          </a:p>
-        </p:txBody>
-      </p:sp>
-      <p:sp>
-        <p:nvSpPr>
-          <p:cNvPr id="11" name="Rectangle 10"/>
-          <p:cNvSpPr/>
-          <p:nvPr/>
-        </p:nvSpPr>
-        <p:spPr>
-          <a:xfrm>
-            <a:off x="0" y="6510528"/>
-            <a:ext cx="12188952" cy="347472"/>
-          </a:xfrm>
-          <a:prstGeom prst="rect">
-            <a:avLst/>
-          </a:prstGeom>
-          <a:solidFill>
-            <a:srgbClr val="0A1937"/>
-          </a:solidFill>
-          <a:ln>
-            <a:noFill/>
-          </a:ln>
-        </p:spPr>
-        <p:style>
-          <a:lnRef idx="1">
-            <a:schemeClr val="accent1"/>
-          </a:lnRef>
-          <a:fillRef idx="3">
-            <a:schemeClr val="accent1"/>
-          </a:fillRef>
-          <a:effectRef idx="2">
-            <a:schemeClr val="accent1"/>
-          </a:effectRef>
-          <a:fontRef idx="minor">
-            <a:schemeClr val="lt1"/>
-          </a:fontRef>
-        </p:style>
-        <p:txBody>
-          <a:bodyPr rtlCol="0" anchor="ctr"/>
-          <a:lstStyle/>
-          <a:p>
-            <a:pPr algn="ctr"/>
-          </a:p>
-        </p:txBody>
-      </p:sp>
-      <p:sp>
-        <p:nvSpPr>
-          <p:cNvPr id="12" name="TextBox 11"/>
-          <p:cNvSpPr txBox="1"/>
-          <p:nvPr/>
-        </p:nvSpPr>
-        <p:spPr>
-          <a:xfrm>
-            <a:off x="685800" y="6583680"/>
-            <a:ext cx="6490411" cy="256032"/>
+            <a:off x="685800" y="6355080"/>
+            <a:ext cx="10817352" cy="274320"/>
           </a:xfrm>
           <a:prstGeom prst="rect">
             <a:avLst/>
@@ -8054,7 +10210,7 @@
             <a:r>
               <a:rPr sz="700">
                 <a:solidFill>
-                  <a:srgbClr val="A0B4D2"/>
+                  <a:srgbClr val="8CA0C3"/>
                 </a:solidFill>
                 <a:latin typeface="Consolas"/>
               </a:rPr>
@@ -8318,7 +10474,7 @@
                 </a:solidFill>
                 <a:latin typeface="Arial"/>
               </a:rPr>
-              <a:t>Reflexionsfragen</a:t>
+              <a:t>Produkte, Verbund und der Kreditprozess</a:t>
             </a:r>
           </a:p>
         </p:txBody>
@@ -8340,10 +10496,48 @@
           <a:noFill/>
         </p:spPr>
         <p:txBody>
-          <a:bodyPr wrap="square" anchor="ctr">
+          <a:bodyPr wrap="square">
             <a:spAutoFit/>
           </a:bodyPr>
           <a:lstStyle/>
+          <a:p>
+            <a:pPr marL="177800" indent="-177800">
+              <a:spcBef>
+                <a:spcPts val="600"/>
+              </a:spcBef>
+              <a:spcAft>
+                <a:spcPts val="200"/>
+              </a:spcAft>
+            </a:pPr>
+            <a:r>
+              <a:rPr sz="1200" i="1">
+                <a:solidFill>
+                  <a:srgbClr val="3D5466"/>
+                </a:solidFill>
+                <a:latin typeface="Arial"/>
+              </a:rPr>
+              <a:t>→  Das Votum liegt immer bei der Marktfolge – nie beim Markt oder der Assistenz. Wer den Prozess kennt, findet für jeden Fall die richtige Stelle.</a:t>
+            </a:r>
+          </a:p>
+          <a:p>
+            <a:pPr>
+              <a:spcBef>
+                <a:spcPts val="1000"/>
+              </a:spcBef>
+              <a:spcAft>
+                <a:spcPts val="200"/>
+              </a:spcAft>
+            </a:pPr>
+            <a:r>
+              <a:rPr sz="800" b="1">
+                <a:solidFill>
+                  <a:srgbClr val="78808C"/>
+                </a:solidFill>
+                <a:latin typeface="Consolas"/>
+              </a:rPr>
+              <a:t>PRODUKTE &amp; VERBUND</a:t>
+            </a:r>
+          </a:p>
           <a:p>
             <a:pPr marL="190500" indent="-190500">
               <a:spcBef>
@@ -8360,7 +10554,26 @@
                 </a:solidFill>
                 <a:latin typeface="Arial"/>
               </a:rPr>
-              <a:t>▸  Nehmen Sie sich fünf Minuten Zeit und beantworten Sie die folgenden Fragen schriftlich. Es gibt keine richtigen oder falschen Antworten – die Reflexion dient Ihrer eigenen Orientierung.</a:t>
+              <a:t>▸  Kredit, Zahlungsverkehr und Verbundpartner (R+V, Union Investment, DZ Bank, KfW/L-Bank).</a:t>
+            </a:r>
+          </a:p>
+          <a:p>
+            <a:pPr>
+              <a:spcBef>
+                <a:spcPts val="1000"/>
+              </a:spcBef>
+              <a:spcAft>
+                <a:spcPts val="200"/>
+              </a:spcAft>
+            </a:pPr>
+            <a:r>
+              <a:rPr sz="800" b="1">
+                <a:solidFill>
+                  <a:srgbClr val="78808C"/>
+                </a:solidFill>
+                <a:latin typeface="Consolas"/>
+              </a:rPr>
+              <a:t>KREDITPROZESS IN SIEBEN PHASEN</a:t>
             </a:r>
           </a:p>
           <a:p>
@@ -8379,7 +10592,7 @@
                 </a:solidFill>
                 <a:latin typeface="Arial"/>
               </a:rPr>
-              <a:t>▸  Welches der vier Orientierungsfelder (Produkte &amp; Verbund, Prozesse &amp; Rollen, Systeme, Erwartungen &amp; Schnittstellen) erscheint Ihnen im Moment am unklarsten? Was wäre Ihr nächster Schritt, um dort Sicherheit zu gewinnen?</a:t>
+              <a:t>▸  Von der Anbahnung bis zur Bestandsbearbeitung; die Assistenz trägt die Phasen 2, 5 und 7.</a:t>
             </a:r>
           </a:p>
           <a:p>
@@ -8398,26 +10611,7 @@
                 </a:solidFill>
                 <a:latin typeface="Arial"/>
               </a:rPr>
-              <a:t>▸  Stellen Sie sich vor, ein Firmenkunde ruft an und möchte wissen, ob sein Antrag schon bearbeitet wurde. In welchem System schauen Sie nach? Wen fragen Sie, wenn Sie die Antwort dort nicht finden?</a:t>
-            </a:r>
-          </a:p>
-          <a:p>
-            <a:pPr marL="190500" indent="-190500">
-              <a:spcBef>
-                <a:spcPts val="400"/>
-              </a:spcBef>
-              <a:spcAft>
-                <a:spcPts val="200"/>
-              </a:spcAft>
-            </a:pPr>
-            <a:r>
-              <a:rPr sz="1300">
-                <a:solidFill>
-                  <a:srgbClr val="3D5466"/>
-                </a:solidFill>
-                <a:latin typeface="Arial"/>
-              </a:rPr>
-              <a:t>▸  Worin unterscheidet sich die Aufgabe der Assistenz von der Aufgabe des Beraters? Was gehört zu Ihrer Verantwortung – und was nicht?</a:t>
+              <a:t>▸  Funktionstrennung Markt/Marktfolge (MaRisk BTO 1.2): getrennte, unabhängige Risikobeurteilung.</a:t>
             </a:r>
           </a:p>
         </p:txBody>

</xml_diff>